<commit_message>
Update to Day12 files.
</commit_message>
<xml_diff>
--- a/Day12/12-paev-andmetarkus-esitlus.pptx
+++ b/Day12/12-paev-andmetarkus-esitlus.pptx
@@ -5,10 +5,10 @@
     <p:sldMasterId id="2147483648" r:id="rId4"/>
   </p:sldMasterIdLst>
   <p:notesMasterIdLst>
-    <p:notesMasterId r:id="rId31"/>
+    <p:notesMasterId r:id="rId34"/>
   </p:notesMasterIdLst>
   <p:handoutMasterIdLst>
-    <p:handoutMasterId r:id="rId32"/>
+    <p:handoutMasterId r:id="rId35"/>
   </p:handoutMasterIdLst>
   <p:sldIdLst>
     <p:sldId id="417" r:id="rId5"/>
@@ -34,35 +34,45 @@
     <p:sldId id="502" r:id="rId25"/>
     <p:sldId id="497" r:id="rId26"/>
     <p:sldId id="561" r:id="rId27"/>
-    <p:sldId id="657" r:id="rId28"/>
-    <p:sldId id="621" r:id="rId29"/>
-    <p:sldId id="658" r:id="rId30"/>
+    <p:sldId id="574" r:id="rId28"/>
+    <p:sldId id="659" r:id="rId29"/>
+    <p:sldId id="660" r:id="rId30"/>
+    <p:sldId id="657" r:id="rId31"/>
+    <p:sldId id="621" r:id="rId32"/>
+    <p:sldId id="658" r:id="rId33"/>
   </p:sldIdLst>
   <p:sldSz cx="12192000" cy="6858000"/>
   <p:notesSz cx="6858000" cy="9144000"/>
   <p:embeddedFontLst>
     <p:embeddedFont>
       <p:font typeface="Inter" panose="020B0604020202020204" charset="0"/>
-      <p:regular r:id="rId33"/>
-      <p:bold r:id="rId34"/>
-      <p:italic r:id="rId35"/>
-      <p:boldItalic r:id="rId36"/>
+      <p:regular r:id="rId36"/>
+      <p:bold r:id="rId37"/>
+      <p:italic r:id="rId38"/>
+      <p:boldItalic r:id="rId39"/>
     </p:embeddedFont>
     <p:embeddedFont>
       <p:font typeface="Inter Bold" panose="020B0604020202020204" charset="0"/>
-      <p:bold r:id="rId37"/>
+      <p:bold r:id="rId40"/>
+    </p:embeddedFont>
+    <p:embeddedFont>
+      <p:font typeface="Noto Serif" panose="02020600060500020200" pitchFamily="18" charset="0"/>
+      <p:regular r:id="rId41"/>
+      <p:bold r:id="rId42"/>
+      <p:italic r:id="rId43"/>
+      <p:boldItalic r:id="rId44"/>
     </p:embeddedFont>
     <p:embeddedFont>
       <p:font typeface="Poppins SemiBold" panose="00000700000000000000" pitchFamily="2" charset="0"/>
-      <p:bold r:id="rId38"/>
-      <p:boldItalic r:id="rId39"/>
+      <p:bold r:id="rId45"/>
+      <p:boldItalic r:id="rId46"/>
     </p:embeddedFont>
     <p:embeddedFont>
       <p:font typeface="Roboto" panose="02000000000000000000" pitchFamily="2" charset="0"/>
-      <p:regular r:id="rId40"/>
-      <p:bold r:id="rId41"/>
-      <p:italic r:id="rId42"/>
-      <p:boldItalic r:id="rId43"/>
+      <p:regular r:id="rId47"/>
+      <p:bold r:id="rId48"/>
+      <p:italic r:id="rId49"/>
+      <p:boldItalic r:id="rId50"/>
     </p:embeddedFont>
   </p:embeddedFontLst>
   <p:defaultTextStyle>
@@ -174,7 +184,7 @@
 <file path=ppt/revisionInfo.xml><?xml version="1.0" encoding="utf-8"?>
 <p1510:revInfo xmlns:a="http://schemas.openxmlformats.org/drawingml/2006/main" xmlns:r="http://schemas.openxmlformats.org/officeDocument/2006/relationships" xmlns:p1510="http://schemas.microsoft.com/office/powerpoint/2015/10/main">
   <p1510:revLst>
-    <p1510:client id="{B4B09D37-9C75-40EB-A9D0-8BDF00BF6831}" v="385" dt="2026-04-14T07:35:10.767"/>
+    <p1510:client id="{B4B09D37-9C75-40EB-A9D0-8BDF00BF6831}" v="386" dt="2026-04-15T10:03:41.647"/>
   </p1510:revLst>
 </p1510:revInfo>
 </file>
@@ -184,7 +194,7 @@
   <pc:docChgLst>
     <pc:chgData name="Virve Räni" userId="161a7437-7ef4-49ec-91bf-54882f313dfe" providerId="ADAL" clId="{6D754EED-65AA-4A21-B175-6769012CF487}"/>
     <pc:docChg chg="undo custSel addSld delSld modSld sldOrd">
-      <pc:chgData name="Virve Räni" userId="161a7437-7ef4-49ec-91bf-54882f313dfe" providerId="ADAL" clId="{6D754EED-65AA-4A21-B175-6769012CF487}" dt="2026-04-14T07:37:34.911" v="1683" actId="20577"/>
+      <pc:chgData name="Virve Räni" userId="161a7437-7ef4-49ec-91bf-54882f313dfe" providerId="ADAL" clId="{6D754EED-65AA-4A21-B175-6769012CF487}" dt="2026-04-15T10:12:18.229" v="2098" actId="790"/>
       <pc:docMkLst>
         <pc:docMk/>
       </pc:docMkLst>
@@ -220,13 +230,13 @@
         </pc:grpChg>
       </pc:sldChg>
       <pc:sldChg chg="modSp mod">
-        <pc:chgData name="Virve Räni" userId="161a7437-7ef4-49ec-91bf-54882f313dfe" providerId="ADAL" clId="{6D754EED-65AA-4A21-B175-6769012CF487}" dt="2026-04-14T07:35:42.301" v="1510" actId="790"/>
+        <pc:chgData name="Virve Räni" userId="161a7437-7ef4-49ec-91bf-54882f313dfe" providerId="ADAL" clId="{6D754EED-65AA-4A21-B175-6769012CF487}" dt="2026-04-15T10:12:18.229" v="2098" actId="790"/>
         <pc:sldMkLst>
           <pc:docMk/>
           <pc:sldMk cId="4169291970" sldId="417"/>
         </pc:sldMkLst>
         <pc:spChg chg="mod">
-          <ac:chgData name="Virve Räni" userId="161a7437-7ef4-49ec-91bf-54882f313dfe" providerId="ADAL" clId="{6D754EED-65AA-4A21-B175-6769012CF487}" dt="2026-04-14T07:35:42.301" v="1510" actId="790"/>
+          <ac:chgData name="Virve Räni" userId="161a7437-7ef4-49ec-91bf-54882f313dfe" providerId="ADAL" clId="{6D754EED-65AA-4A21-B175-6769012CF487}" dt="2026-04-15T10:12:18.229" v="2098" actId="790"/>
           <ac:spMkLst>
             <pc:docMk/>
             <pc:sldMk cId="4169291970" sldId="417"/>
@@ -234,7 +244,7 @@
           </ac:spMkLst>
         </pc:spChg>
         <pc:spChg chg="mod">
-          <ac:chgData name="Virve Räni" userId="161a7437-7ef4-49ec-91bf-54882f313dfe" providerId="ADAL" clId="{6D754EED-65AA-4A21-B175-6769012CF487}" dt="2026-04-14T07:35:42.301" v="1510" actId="790"/>
+          <ac:chgData name="Virve Räni" userId="161a7437-7ef4-49ec-91bf-54882f313dfe" providerId="ADAL" clId="{6D754EED-65AA-4A21-B175-6769012CF487}" dt="2026-04-15T10:12:18.229" v="2098" actId="790"/>
           <ac:spMkLst>
             <pc:docMk/>
             <pc:sldMk cId="4169291970" sldId="417"/>
@@ -250,13 +260,13 @@
         </pc:sldMkLst>
       </pc:sldChg>
       <pc:sldChg chg="modSp mod">
-        <pc:chgData name="Virve Räni" userId="161a7437-7ef4-49ec-91bf-54882f313dfe" providerId="ADAL" clId="{6D754EED-65AA-4A21-B175-6769012CF487}" dt="2026-04-14T07:35:42.301" v="1510" actId="790"/>
+        <pc:chgData name="Virve Räni" userId="161a7437-7ef4-49ec-91bf-54882f313dfe" providerId="ADAL" clId="{6D754EED-65AA-4A21-B175-6769012CF487}" dt="2026-04-15T10:12:18.229" v="2098" actId="790"/>
         <pc:sldMkLst>
           <pc:docMk/>
           <pc:sldMk cId="971682894" sldId="452"/>
         </pc:sldMkLst>
         <pc:spChg chg="mod">
-          <ac:chgData name="Virve Räni" userId="161a7437-7ef4-49ec-91bf-54882f313dfe" providerId="ADAL" clId="{6D754EED-65AA-4A21-B175-6769012CF487}" dt="2026-04-14T07:35:42.301" v="1510" actId="790"/>
+          <ac:chgData name="Virve Räni" userId="161a7437-7ef4-49ec-91bf-54882f313dfe" providerId="ADAL" clId="{6D754EED-65AA-4A21-B175-6769012CF487}" dt="2026-04-15T10:12:18.229" v="2098" actId="790"/>
           <ac:spMkLst>
             <pc:docMk/>
             <pc:sldMk cId="971682894" sldId="452"/>
@@ -264,7 +274,7 @@
           </ac:spMkLst>
         </pc:spChg>
         <pc:spChg chg="mod">
-          <ac:chgData name="Virve Räni" userId="161a7437-7ef4-49ec-91bf-54882f313dfe" providerId="ADAL" clId="{6D754EED-65AA-4A21-B175-6769012CF487}" dt="2026-04-14T07:35:42.301" v="1510" actId="790"/>
+          <ac:chgData name="Virve Räni" userId="161a7437-7ef4-49ec-91bf-54882f313dfe" providerId="ADAL" clId="{6D754EED-65AA-4A21-B175-6769012CF487}" dt="2026-04-15T10:12:18.229" v="2098" actId="790"/>
           <ac:spMkLst>
             <pc:docMk/>
             <pc:sldMk cId="971682894" sldId="452"/>
@@ -273,13 +283,13 @@
         </pc:spChg>
       </pc:sldChg>
       <pc:sldChg chg="modSp mod">
-        <pc:chgData name="Virve Räni" userId="161a7437-7ef4-49ec-91bf-54882f313dfe" providerId="ADAL" clId="{6D754EED-65AA-4A21-B175-6769012CF487}" dt="2026-04-14T07:35:42.301" v="1510" actId="790"/>
+        <pc:chgData name="Virve Räni" userId="161a7437-7ef4-49ec-91bf-54882f313dfe" providerId="ADAL" clId="{6D754EED-65AA-4A21-B175-6769012CF487}" dt="2026-04-15T10:12:18.229" v="2098" actId="790"/>
         <pc:sldMkLst>
           <pc:docMk/>
           <pc:sldMk cId="1605723234" sldId="453"/>
         </pc:sldMkLst>
         <pc:spChg chg="mod">
-          <ac:chgData name="Virve Räni" userId="161a7437-7ef4-49ec-91bf-54882f313dfe" providerId="ADAL" clId="{6D754EED-65AA-4A21-B175-6769012CF487}" dt="2026-04-14T07:35:42.301" v="1510" actId="790"/>
+          <ac:chgData name="Virve Räni" userId="161a7437-7ef4-49ec-91bf-54882f313dfe" providerId="ADAL" clId="{6D754EED-65AA-4A21-B175-6769012CF487}" dt="2026-04-15T10:12:18.229" v="2098" actId="790"/>
           <ac:spMkLst>
             <pc:docMk/>
             <pc:sldMk cId="1605723234" sldId="453"/>
@@ -287,7 +297,7 @@
           </ac:spMkLst>
         </pc:spChg>
         <pc:spChg chg="mod">
-          <ac:chgData name="Virve Räni" userId="161a7437-7ef4-49ec-91bf-54882f313dfe" providerId="ADAL" clId="{6D754EED-65AA-4A21-B175-6769012CF487}" dt="2026-04-14T07:35:42.301" v="1510" actId="790"/>
+          <ac:chgData name="Virve Räni" userId="161a7437-7ef4-49ec-91bf-54882f313dfe" providerId="ADAL" clId="{6D754EED-65AA-4A21-B175-6769012CF487}" dt="2026-04-15T10:12:18.229" v="2098" actId="790"/>
           <ac:spMkLst>
             <pc:docMk/>
             <pc:sldMk cId="1605723234" sldId="453"/>
@@ -295,7 +305,7 @@
           </ac:spMkLst>
         </pc:spChg>
         <pc:graphicFrameChg chg="modGraphic">
-          <ac:chgData name="Virve Räni" userId="161a7437-7ef4-49ec-91bf-54882f313dfe" providerId="ADAL" clId="{6D754EED-65AA-4A21-B175-6769012CF487}" dt="2026-04-14T07:35:42.301" v="1510" actId="790"/>
+          <ac:chgData name="Virve Räni" userId="161a7437-7ef4-49ec-91bf-54882f313dfe" providerId="ADAL" clId="{6D754EED-65AA-4A21-B175-6769012CF487}" dt="2026-04-15T10:12:18.229" v="2098" actId="790"/>
           <ac:graphicFrameMkLst>
             <pc:docMk/>
             <pc:sldMk cId="1605723234" sldId="453"/>
@@ -304,13 +314,13 @@
         </pc:graphicFrameChg>
       </pc:sldChg>
       <pc:sldChg chg="modSp mod">
-        <pc:chgData name="Virve Räni" userId="161a7437-7ef4-49ec-91bf-54882f313dfe" providerId="ADAL" clId="{6D754EED-65AA-4A21-B175-6769012CF487}" dt="2026-04-14T07:35:42.301" v="1510" actId="790"/>
+        <pc:chgData name="Virve Räni" userId="161a7437-7ef4-49ec-91bf-54882f313dfe" providerId="ADAL" clId="{6D754EED-65AA-4A21-B175-6769012CF487}" dt="2026-04-15T10:12:18.229" v="2098" actId="790"/>
         <pc:sldMkLst>
           <pc:docMk/>
           <pc:sldMk cId="2627330612" sldId="454"/>
         </pc:sldMkLst>
         <pc:spChg chg="mod">
-          <ac:chgData name="Virve Räni" userId="161a7437-7ef4-49ec-91bf-54882f313dfe" providerId="ADAL" clId="{6D754EED-65AA-4A21-B175-6769012CF487}" dt="2026-04-14T07:35:42.301" v="1510" actId="790"/>
+          <ac:chgData name="Virve Räni" userId="161a7437-7ef4-49ec-91bf-54882f313dfe" providerId="ADAL" clId="{6D754EED-65AA-4A21-B175-6769012CF487}" dt="2026-04-15T10:12:18.229" v="2098" actId="790"/>
           <ac:spMkLst>
             <pc:docMk/>
             <pc:sldMk cId="2627330612" sldId="454"/>
@@ -318,7 +328,7 @@
           </ac:spMkLst>
         </pc:spChg>
         <pc:spChg chg="mod">
-          <ac:chgData name="Virve Räni" userId="161a7437-7ef4-49ec-91bf-54882f313dfe" providerId="ADAL" clId="{6D754EED-65AA-4A21-B175-6769012CF487}" dt="2026-04-14T07:35:42.301" v="1510" actId="790"/>
+          <ac:chgData name="Virve Räni" userId="161a7437-7ef4-49ec-91bf-54882f313dfe" providerId="ADAL" clId="{6D754EED-65AA-4A21-B175-6769012CF487}" dt="2026-04-15T10:12:18.229" v="2098" actId="790"/>
           <ac:spMkLst>
             <pc:docMk/>
             <pc:sldMk cId="2627330612" sldId="454"/>
@@ -326,7 +336,7 @@
           </ac:spMkLst>
         </pc:spChg>
         <pc:graphicFrameChg chg="modGraphic">
-          <ac:chgData name="Virve Räni" userId="161a7437-7ef4-49ec-91bf-54882f313dfe" providerId="ADAL" clId="{6D754EED-65AA-4A21-B175-6769012CF487}" dt="2026-04-14T07:35:42.301" v="1510" actId="790"/>
+          <ac:chgData name="Virve Räni" userId="161a7437-7ef4-49ec-91bf-54882f313dfe" providerId="ADAL" clId="{6D754EED-65AA-4A21-B175-6769012CF487}" dt="2026-04-15T10:12:18.229" v="2098" actId="790"/>
           <ac:graphicFrameMkLst>
             <pc:docMk/>
             <pc:sldMk cId="2627330612" sldId="454"/>
@@ -335,13 +345,13 @@
         </pc:graphicFrameChg>
       </pc:sldChg>
       <pc:sldChg chg="modSp mod">
-        <pc:chgData name="Virve Räni" userId="161a7437-7ef4-49ec-91bf-54882f313dfe" providerId="ADAL" clId="{6D754EED-65AA-4A21-B175-6769012CF487}" dt="2026-04-14T07:35:42.301" v="1510" actId="790"/>
+        <pc:chgData name="Virve Räni" userId="161a7437-7ef4-49ec-91bf-54882f313dfe" providerId="ADAL" clId="{6D754EED-65AA-4A21-B175-6769012CF487}" dt="2026-04-15T10:12:18.229" v="2098" actId="790"/>
         <pc:sldMkLst>
           <pc:docMk/>
           <pc:sldMk cId="2153243940" sldId="455"/>
         </pc:sldMkLst>
         <pc:spChg chg="mod">
-          <ac:chgData name="Virve Räni" userId="161a7437-7ef4-49ec-91bf-54882f313dfe" providerId="ADAL" clId="{6D754EED-65AA-4A21-B175-6769012CF487}" dt="2026-04-14T07:35:42.301" v="1510" actId="790"/>
+          <ac:chgData name="Virve Räni" userId="161a7437-7ef4-49ec-91bf-54882f313dfe" providerId="ADAL" clId="{6D754EED-65AA-4A21-B175-6769012CF487}" dt="2026-04-15T10:12:18.229" v="2098" actId="790"/>
           <ac:spMkLst>
             <pc:docMk/>
             <pc:sldMk cId="2153243940" sldId="455"/>
@@ -349,7 +359,7 @@
           </ac:spMkLst>
         </pc:spChg>
         <pc:spChg chg="mod">
-          <ac:chgData name="Virve Räni" userId="161a7437-7ef4-49ec-91bf-54882f313dfe" providerId="ADAL" clId="{6D754EED-65AA-4A21-B175-6769012CF487}" dt="2026-04-14T07:35:42.301" v="1510" actId="790"/>
+          <ac:chgData name="Virve Räni" userId="161a7437-7ef4-49ec-91bf-54882f313dfe" providerId="ADAL" clId="{6D754EED-65AA-4A21-B175-6769012CF487}" dt="2026-04-15T10:12:18.229" v="2098" actId="790"/>
           <ac:spMkLst>
             <pc:docMk/>
             <pc:sldMk cId="2153243940" sldId="455"/>
@@ -358,13 +368,13 @@
         </pc:spChg>
       </pc:sldChg>
       <pc:sldChg chg="modSp mod">
-        <pc:chgData name="Virve Räni" userId="161a7437-7ef4-49ec-91bf-54882f313dfe" providerId="ADAL" clId="{6D754EED-65AA-4A21-B175-6769012CF487}" dt="2026-04-14T07:35:42.301" v="1510" actId="790"/>
+        <pc:chgData name="Virve Räni" userId="161a7437-7ef4-49ec-91bf-54882f313dfe" providerId="ADAL" clId="{6D754EED-65AA-4A21-B175-6769012CF487}" dt="2026-04-15T10:12:18.229" v="2098" actId="790"/>
         <pc:sldMkLst>
           <pc:docMk/>
           <pc:sldMk cId="1758259910" sldId="456"/>
         </pc:sldMkLst>
         <pc:spChg chg="mod">
-          <ac:chgData name="Virve Räni" userId="161a7437-7ef4-49ec-91bf-54882f313dfe" providerId="ADAL" clId="{6D754EED-65AA-4A21-B175-6769012CF487}" dt="2026-04-14T07:35:42.301" v="1510" actId="790"/>
+          <ac:chgData name="Virve Räni" userId="161a7437-7ef4-49ec-91bf-54882f313dfe" providerId="ADAL" clId="{6D754EED-65AA-4A21-B175-6769012CF487}" dt="2026-04-15T10:12:18.229" v="2098" actId="790"/>
           <ac:spMkLst>
             <pc:docMk/>
             <pc:sldMk cId="1758259910" sldId="456"/>
@@ -372,7 +382,7 @@
           </ac:spMkLst>
         </pc:spChg>
         <pc:spChg chg="mod">
-          <ac:chgData name="Virve Räni" userId="161a7437-7ef4-49ec-91bf-54882f313dfe" providerId="ADAL" clId="{6D754EED-65AA-4A21-B175-6769012CF487}" dt="2026-04-14T07:35:42.301" v="1510" actId="790"/>
+          <ac:chgData name="Virve Räni" userId="161a7437-7ef4-49ec-91bf-54882f313dfe" providerId="ADAL" clId="{6D754EED-65AA-4A21-B175-6769012CF487}" dt="2026-04-15T10:12:18.229" v="2098" actId="790"/>
           <ac:spMkLst>
             <pc:docMk/>
             <pc:sldMk cId="1758259910" sldId="456"/>
@@ -380,7 +390,7 @@
           </ac:spMkLst>
         </pc:spChg>
         <pc:graphicFrameChg chg="modGraphic">
-          <ac:chgData name="Virve Räni" userId="161a7437-7ef4-49ec-91bf-54882f313dfe" providerId="ADAL" clId="{6D754EED-65AA-4A21-B175-6769012CF487}" dt="2026-04-14T07:35:42.301" v="1510" actId="790"/>
+          <ac:chgData name="Virve Räni" userId="161a7437-7ef4-49ec-91bf-54882f313dfe" providerId="ADAL" clId="{6D754EED-65AA-4A21-B175-6769012CF487}" dt="2026-04-15T10:12:18.229" v="2098" actId="790"/>
           <ac:graphicFrameMkLst>
             <pc:docMk/>
             <pc:sldMk cId="1758259910" sldId="456"/>
@@ -389,13 +399,13 @@
         </pc:graphicFrameChg>
       </pc:sldChg>
       <pc:sldChg chg="modSp mod ord">
-        <pc:chgData name="Virve Räni" userId="161a7437-7ef4-49ec-91bf-54882f313dfe" providerId="ADAL" clId="{6D754EED-65AA-4A21-B175-6769012CF487}" dt="2026-04-14T07:35:42.301" v="1510" actId="790"/>
+        <pc:chgData name="Virve Räni" userId="161a7437-7ef4-49ec-91bf-54882f313dfe" providerId="ADAL" clId="{6D754EED-65AA-4A21-B175-6769012CF487}" dt="2026-04-15T10:12:18.229" v="2098" actId="790"/>
         <pc:sldMkLst>
           <pc:docMk/>
           <pc:sldMk cId="868596080" sldId="458"/>
         </pc:sldMkLst>
         <pc:spChg chg="mod">
-          <ac:chgData name="Virve Räni" userId="161a7437-7ef4-49ec-91bf-54882f313dfe" providerId="ADAL" clId="{6D754EED-65AA-4A21-B175-6769012CF487}" dt="2026-04-14T07:35:42.301" v="1510" actId="790"/>
+          <ac:chgData name="Virve Räni" userId="161a7437-7ef4-49ec-91bf-54882f313dfe" providerId="ADAL" clId="{6D754EED-65AA-4A21-B175-6769012CF487}" dt="2026-04-15T10:12:18.229" v="2098" actId="790"/>
           <ac:spMkLst>
             <pc:docMk/>
             <pc:sldMk cId="868596080" sldId="458"/>
@@ -403,7 +413,7 @@
           </ac:spMkLst>
         </pc:spChg>
         <pc:spChg chg="mod">
-          <ac:chgData name="Virve Räni" userId="161a7437-7ef4-49ec-91bf-54882f313dfe" providerId="ADAL" clId="{6D754EED-65AA-4A21-B175-6769012CF487}" dt="2026-04-14T07:35:42.301" v="1510" actId="790"/>
+          <ac:chgData name="Virve Räni" userId="161a7437-7ef4-49ec-91bf-54882f313dfe" providerId="ADAL" clId="{6D754EED-65AA-4A21-B175-6769012CF487}" dt="2026-04-15T10:12:18.229" v="2098" actId="790"/>
           <ac:spMkLst>
             <pc:docMk/>
             <pc:sldMk cId="868596080" sldId="458"/>
@@ -412,13 +422,13 @@
         </pc:spChg>
       </pc:sldChg>
       <pc:sldChg chg="modSp mod ord">
-        <pc:chgData name="Virve Räni" userId="161a7437-7ef4-49ec-91bf-54882f313dfe" providerId="ADAL" clId="{6D754EED-65AA-4A21-B175-6769012CF487}" dt="2026-04-14T07:35:42.301" v="1510" actId="790"/>
+        <pc:chgData name="Virve Räni" userId="161a7437-7ef4-49ec-91bf-54882f313dfe" providerId="ADAL" clId="{6D754EED-65AA-4A21-B175-6769012CF487}" dt="2026-04-15T10:12:18.229" v="2098" actId="790"/>
         <pc:sldMkLst>
           <pc:docMk/>
           <pc:sldMk cId="1174531915" sldId="459"/>
         </pc:sldMkLst>
         <pc:spChg chg="mod">
-          <ac:chgData name="Virve Räni" userId="161a7437-7ef4-49ec-91bf-54882f313dfe" providerId="ADAL" clId="{6D754EED-65AA-4A21-B175-6769012CF487}" dt="2026-04-14T07:35:42.301" v="1510" actId="790"/>
+          <ac:chgData name="Virve Räni" userId="161a7437-7ef4-49ec-91bf-54882f313dfe" providerId="ADAL" clId="{6D754EED-65AA-4A21-B175-6769012CF487}" dt="2026-04-15T10:12:18.229" v="2098" actId="790"/>
           <ac:spMkLst>
             <pc:docMk/>
             <pc:sldMk cId="1174531915" sldId="459"/>
@@ -426,7 +436,7 @@
           </ac:spMkLst>
         </pc:spChg>
         <pc:spChg chg="mod">
-          <ac:chgData name="Virve Räni" userId="161a7437-7ef4-49ec-91bf-54882f313dfe" providerId="ADAL" clId="{6D754EED-65AA-4A21-B175-6769012CF487}" dt="2026-04-14T07:35:42.301" v="1510" actId="790"/>
+          <ac:chgData name="Virve Räni" userId="161a7437-7ef4-49ec-91bf-54882f313dfe" providerId="ADAL" clId="{6D754EED-65AA-4A21-B175-6769012CF487}" dt="2026-04-15T10:12:18.229" v="2098" actId="790"/>
           <ac:spMkLst>
             <pc:docMk/>
             <pc:sldMk cId="1174531915" sldId="459"/>
@@ -435,13 +445,13 @@
         </pc:spChg>
       </pc:sldChg>
       <pc:sldChg chg="modSp mod">
-        <pc:chgData name="Virve Räni" userId="161a7437-7ef4-49ec-91bf-54882f313dfe" providerId="ADAL" clId="{6D754EED-65AA-4A21-B175-6769012CF487}" dt="2026-04-14T07:35:42.301" v="1510" actId="790"/>
+        <pc:chgData name="Virve Räni" userId="161a7437-7ef4-49ec-91bf-54882f313dfe" providerId="ADAL" clId="{6D754EED-65AA-4A21-B175-6769012CF487}" dt="2026-04-15T10:12:18.229" v="2098" actId="790"/>
         <pc:sldMkLst>
           <pc:docMk/>
           <pc:sldMk cId="3621123409" sldId="491"/>
         </pc:sldMkLst>
         <pc:spChg chg="mod">
-          <ac:chgData name="Virve Räni" userId="161a7437-7ef4-49ec-91bf-54882f313dfe" providerId="ADAL" clId="{6D754EED-65AA-4A21-B175-6769012CF487}" dt="2026-04-14T07:35:42.301" v="1510" actId="790"/>
+          <ac:chgData name="Virve Räni" userId="161a7437-7ef4-49ec-91bf-54882f313dfe" providerId="ADAL" clId="{6D754EED-65AA-4A21-B175-6769012CF487}" dt="2026-04-15T10:12:18.229" v="2098" actId="790"/>
           <ac:spMkLst>
             <pc:docMk/>
             <pc:sldMk cId="3621123409" sldId="491"/>
@@ -449,7 +459,7 @@
           </ac:spMkLst>
         </pc:spChg>
         <pc:graphicFrameChg chg="mod modGraphic">
-          <ac:chgData name="Virve Räni" userId="161a7437-7ef4-49ec-91bf-54882f313dfe" providerId="ADAL" clId="{6D754EED-65AA-4A21-B175-6769012CF487}" dt="2026-04-14T07:35:42.301" v="1510" actId="790"/>
+          <ac:chgData name="Virve Räni" userId="161a7437-7ef4-49ec-91bf-54882f313dfe" providerId="ADAL" clId="{6D754EED-65AA-4A21-B175-6769012CF487}" dt="2026-04-15T10:12:18.229" v="2098" actId="790"/>
           <ac:graphicFrameMkLst>
             <pc:docMk/>
             <pc:sldMk cId="3621123409" sldId="491"/>
@@ -458,13 +468,13 @@
         </pc:graphicFrameChg>
       </pc:sldChg>
       <pc:sldChg chg="modSp mod">
-        <pc:chgData name="Virve Räni" userId="161a7437-7ef4-49ec-91bf-54882f313dfe" providerId="ADAL" clId="{6D754EED-65AA-4A21-B175-6769012CF487}" dt="2026-04-14T07:35:42.301" v="1510" actId="790"/>
+        <pc:chgData name="Virve Räni" userId="161a7437-7ef4-49ec-91bf-54882f313dfe" providerId="ADAL" clId="{6D754EED-65AA-4A21-B175-6769012CF487}" dt="2026-04-15T10:12:18.229" v="2098" actId="790"/>
         <pc:sldMkLst>
           <pc:docMk/>
           <pc:sldMk cId="3311797835" sldId="496"/>
         </pc:sldMkLst>
         <pc:spChg chg="mod">
-          <ac:chgData name="Virve Räni" userId="161a7437-7ef4-49ec-91bf-54882f313dfe" providerId="ADAL" clId="{6D754EED-65AA-4A21-B175-6769012CF487}" dt="2026-04-14T07:35:42.301" v="1510" actId="790"/>
+          <ac:chgData name="Virve Räni" userId="161a7437-7ef4-49ec-91bf-54882f313dfe" providerId="ADAL" clId="{6D754EED-65AA-4A21-B175-6769012CF487}" dt="2026-04-15T10:12:18.229" v="2098" actId="790"/>
           <ac:spMkLst>
             <pc:docMk/>
             <pc:sldMk cId="3311797835" sldId="496"/>
@@ -472,7 +482,7 @@
           </ac:spMkLst>
         </pc:spChg>
         <pc:spChg chg="mod">
-          <ac:chgData name="Virve Räni" userId="161a7437-7ef4-49ec-91bf-54882f313dfe" providerId="ADAL" clId="{6D754EED-65AA-4A21-B175-6769012CF487}" dt="2026-04-14T07:35:42.301" v="1510" actId="790"/>
+          <ac:chgData name="Virve Räni" userId="161a7437-7ef4-49ec-91bf-54882f313dfe" providerId="ADAL" clId="{6D754EED-65AA-4A21-B175-6769012CF487}" dt="2026-04-15T10:12:18.229" v="2098" actId="790"/>
           <ac:spMkLst>
             <pc:docMk/>
             <pc:sldMk cId="3311797835" sldId="496"/>
@@ -481,13 +491,13 @@
         </pc:spChg>
       </pc:sldChg>
       <pc:sldChg chg="modSp mod">
-        <pc:chgData name="Virve Räni" userId="161a7437-7ef4-49ec-91bf-54882f313dfe" providerId="ADAL" clId="{6D754EED-65AA-4A21-B175-6769012CF487}" dt="2026-04-14T07:35:42.301" v="1510" actId="790"/>
+        <pc:chgData name="Virve Räni" userId="161a7437-7ef4-49ec-91bf-54882f313dfe" providerId="ADAL" clId="{6D754EED-65AA-4A21-B175-6769012CF487}" dt="2026-04-15T10:12:18.229" v="2098" actId="790"/>
         <pc:sldMkLst>
           <pc:docMk/>
           <pc:sldMk cId="3286914797" sldId="497"/>
         </pc:sldMkLst>
         <pc:spChg chg="mod">
-          <ac:chgData name="Virve Räni" userId="161a7437-7ef4-49ec-91bf-54882f313dfe" providerId="ADAL" clId="{6D754EED-65AA-4A21-B175-6769012CF487}" dt="2026-04-14T07:35:42.301" v="1510" actId="790"/>
+          <ac:chgData name="Virve Räni" userId="161a7437-7ef4-49ec-91bf-54882f313dfe" providerId="ADAL" clId="{6D754EED-65AA-4A21-B175-6769012CF487}" dt="2026-04-15T10:12:18.229" v="2098" actId="790"/>
           <ac:spMkLst>
             <pc:docMk/>
             <pc:sldMk cId="3286914797" sldId="497"/>
@@ -495,7 +505,7 @@
           </ac:spMkLst>
         </pc:spChg>
         <pc:spChg chg="mod">
-          <ac:chgData name="Virve Räni" userId="161a7437-7ef4-49ec-91bf-54882f313dfe" providerId="ADAL" clId="{6D754EED-65AA-4A21-B175-6769012CF487}" dt="2026-04-14T07:35:42.301" v="1510" actId="790"/>
+          <ac:chgData name="Virve Räni" userId="161a7437-7ef4-49ec-91bf-54882f313dfe" providerId="ADAL" clId="{6D754EED-65AA-4A21-B175-6769012CF487}" dt="2026-04-15T10:12:18.229" v="2098" actId="790"/>
           <ac:spMkLst>
             <pc:docMk/>
             <pc:sldMk cId="3286914797" sldId="497"/>
@@ -503,7 +513,7 @@
           </ac:spMkLst>
         </pc:spChg>
         <pc:spChg chg="mod">
-          <ac:chgData name="Virve Räni" userId="161a7437-7ef4-49ec-91bf-54882f313dfe" providerId="ADAL" clId="{6D754EED-65AA-4A21-B175-6769012CF487}" dt="2026-04-14T07:35:42.301" v="1510" actId="790"/>
+          <ac:chgData name="Virve Räni" userId="161a7437-7ef4-49ec-91bf-54882f313dfe" providerId="ADAL" clId="{6D754EED-65AA-4A21-B175-6769012CF487}" dt="2026-04-15T10:12:18.229" v="2098" actId="790"/>
           <ac:spMkLst>
             <pc:docMk/>
             <pc:sldMk cId="3286914797" sldId="497"/>
@@ -512,13 +522,13 @@
         </pc:spChg>
       </pc:sldChg>
       <pc:sldChg chg="modSp mod">
-        <pc:chgData name="Virve Räni" userId="161a7437-7ef4-49ec-91bf-54882f313dfe" providerId="ADAL" clId="{6D754EED-65AA-4A21-B175-6769012CF487}" dt="2026-04-14T07:35:42.301" v="1510" actId="790"/>
+        <pc:chgData name="Virve Räni" userId="161a7437-7ef4-49ec-91bf-54882f313dfe" providerId="ADAL" clId="{6D754EED-65AA-4A21-B175-6769012CF487}" dt="2026-04-15T10:12:18.229" v="2098" actId="790"/>
         <pc:sldMkLst>
           <pc:docMk/>
           <pc:sldMk cId="1892651774" sldId="498"/>
         </pc:sldMkLst>
         <pc:spChg chg="mod">
-          <ac:chgData name="Virve Räni" userId="161a7437-7ef4-49ec-91bf-54882f313dfe" providerId="ADAL" clId="{6D754EED-65AA-4A21-B175-6769012CF487}" dt="2026-04-14T07:35:42.301" v="1510" actId="790"/>
+          <ac:chgData name="Virve Räni" userId="161a7437-7ef4-49ec-91bf-54882f313dfe" providerId="ADAL" clId="{6D754EED-65AA-4A21-B175-6769012CF487}" dt="2026-04-15T10:12:18.229" v="2098" actId="790"/>
           <ac:spMkLst>
             <pc:docMk/>
             <pc:sldMk cId="1892651774" sldId="498"/>
@@ -526,7 +536,7 @@
           </ac:spMkLst>
         </pc:spChg>
         <pc:spChg chg="mod">
-          <ac:chgData name="Virve Räni" userId="161a7437-7ef4-49ec-91bf-54882f313dfe" providerId="ADAL" clId="{6D754EED-65AA-4A21-B175-6769012CF487}" dt="2026-04-14T07:35:42.301" v="1510" actId="790"/>
+          <ac:chgData name="Virve Räni" userId="161a7437-7ef4-49ec-91bf-54882f313dfe" providerId="ADAL" clId="{6D754EED-65AA-4A21-B175-6769012CF487}" dt="2026-04-15T10:12:18.229" v="2098" actId="790"/>
           <ac:spMkLst>
             <pc:docMk/>
             <pc:sldMk cId="1892651774" sldId="498"/>
@@ -535,13 +545,13 @@
         </pc:spChg>
       </pc:sldChg>
       <pc:sldChg chg="modSp mod ord addAnim delAnim modAnim">
-        <pc:chgData name="Virve Räni" userId="161a7437-7ef4-49ec-91bf-54882f313dfe" providerId="ADAL" clId="{6D754EED-65AA-4A21-B175-6769012CF487}" dt="2026-04-14T07:35:42.301" v="1510" actId="790"/>
+        <pc:chgData name="Virve Räni" userId="161a7437-7ef4-49ec-91bf-54882f313dfe" providerId="ADAL" clId="{6D754EED-65AA-4A21-B175-6769012CF487}" dt="2026-04-15T10:12:18.229" v="2098" actId="790"/>
         <pc:sldMkLst>
           <pc:docMk/>
           <pc:sldMk cId="1100480778" sldId="499"/>
         </pc:sldMkLst>
         <pc:spChg chg="mod">
-          <ac:chgData name="Virve Räni" userId="161a7437-7ef4-49ec-91bf-54882f313dfe" providerId="ADAL" clId="{6D754EED-65AA-4A21-B175-6769012CF487}" dt="2026-04-14T07:35:42.301" v="1510" actId="790"/>
+          <ac:chgData name="Virve Räni" userId="161a7437-7ef4-49ec-91bf-54882f313dfe" providerId="ADAL" clId="{6D754EED-65AA-4A21-B175-6769012CF487}" dt="2026-04-15T10:12:18.229" v="2098" actId="790"/>
           <ac:spMkLst>
             <pc:docMk/>
             <pc:sldMk cId="1100480778" sldId="499"/>
@@ -549,7 +559,7 @@
           </ac:spMkLst>
         </pc:spChg>
         <pc:spChg chg="mod">
-          <ac:chgData name="Virve Räni" userId="161a7437-7ef4-49ec-91bf-54882f313dfe" providerId="ADAL" clId="{6D754EED-65AA-4A21-B175-6769012CF487}" dt="2026-04-14T07:35:42.301" v="1510" actId="790"/>
+          <ac:chgData name="Virve Räni" userId="161a7437-7ef4-49ec-91bf-54882f313dfe" providerId="ADAL" clId="{6D754EED-65AA-4A21-B175-6769012CF487}" dt="2026-04-15T10:12:18.229" v="2098" actId="790"/>
           <ac:spMkLst>
             <pc:docMk/>
             <pc:sldMk cId="1100480778" sldId="499"/>
@@ -558,13 +568,13 @@
         </pc:spChg>
       </pc:sldChg>
       <pc:sldChg chg="modSp mod">
-        <pc:chgData name="Virve Räni" userId="161a7437-7ef4-49ec-91bf-54882f313dfe" providerId="ADAL" clId="{6D754EED-65AA-4A21-B175-6769012CF487}" dt="2026-04-14T07:35:42.301" v="1510" actId="790"/>
+        <pc:chgData name="Virve Räni" userId="161a7437-7ef4-49ec-91bf-54882f313dfe" providerId="ADAL" clId="{6D754EED-65AA-4A21-B175-6769012CF487}" dt="2026-04-15T10:12:18.229" v="2098" actId="790"/>
         <pc:sldMkLst>
           <pc:docMk/>
           <pc:sldMk cId="1501543890" sldId="500"/>
         </pc:sldMkLst>
         <pc:spChg chg="mod">
-          <ac:chgData name="Virve Räni" userId="161a7437-7ef4-49ec-91bf-54882f313dfe" providerId="ADAL" clId="{6D754EED-65AA-4A21-B175-6769012CF487}" dt="2026-04-14T07:35:42.301" v="1510" actId="790"/>
+          <ac:chgData name="Virve Räni" userId="161a7437-7ef4-49ec-91bf-54882f313dfe" providerId="ADAL" clId="{6D754EED-65AA-4A21-B175-6769012CF487}" dt="2026-04-15T10:12:18.229" v="2098" actId="790"/>
           <ac:spMkLst>
             <pc:docMk/>
             <pc:sldMk cId="1501543890" sldId="500"/>
@@ -572,7 +582,7 @@
           </ac:spMkLst>
         </pc:spChg>
         <pc:spChg chg="mod">
-          <ac:chgData name="Virve Räni" userId="161a7437-7ef4-49ec-91bf-54882f313dfe" providerId="ADAL" clId="{6D754EED-65AA-4A21-B175-6769012CF487}" dt="2026-04-14T07:35:42.301" v="1510" actId="790"/>
+          <ac:chgData name="Virve Räni" userId="161a7437-7ef4-49ec-91bf-54882f313dfe" providerId="ADAL" clId="{6D754EED-65AA-4A21-B175-6769012CF487}" dt="2026-04-15T10:12:18.229" v="2098" actId="790"/>
           <ac:spMkLst>
             <pc:docMk/>
             <pc:sldMk cId="1501543890" sldId="500"/>
@@ -580,7 +590,7 @@
           </ac:spMkLst>
         </pc:spChg>
         <pc:spChg chg="mod">
-          <ac:chgData name="Virve Räni" userId="161a7437-7ef4-49ec-91bf-54882f313dfe" providerId="ADAL" clId="{6D754EED-65AA-4A21-B175-6769012CF487}" dt="2026-04-14T07:35:42.301" v="1510" actId="790"/>
+          <ac:chgData name="Virve Räni" userId="161a7437-7ef4-49ec-91bf-54882f313dfe" providerId="ADAL" clId="{6D754EED-65AA-4A21-B175-6769012CF487}" dt="2026-04-15T10:12:18.229" v="2098" actId="790"/>
           <ac:spMkLst>
             <pc:docMk/>
             <pc:sldMk cId="1501543890" sldId="500"/>
@@ -589,13 +599,13 @@
         </pc:spChg>
       </pc:sldChg>
       <pc:sldChg chg="modSp mod">
-        <pc:chgData name="Virve Räni" userId="161a7437-7ef4-49ec-91bf-54882f313dfe" providerId="ADAL" clId="{6D754EED-65AA-4A21-B175-6769012CF487}" dt="2026-04-14T07:35:42.301" v="1510" actId="790"/>
+        <pc:chgData name="Virve Räni" userId="161a7437-7ef4-49ec-91bf-54882f313dfe" providerId="ADAL" clId="{6D754EED-65AA-4A21-B175-6769012CF487}" dt="2026-04-15T10:12:18.229" v="2098" actId="790"/>
         <pc:sldMkLst>
           <pc:docMk/>
           <pc:sldMk cId="1505008034" sldId="502"/>
         </pc:sldMkLst>
         <pc:spChg chg="mod">
-          <ac:chgData name="Virve Räni" userId="161a7437-7ef4-49ec-91bf-54882f313dfe" providerId="ADAL" clId="{6D754EED-65AA-4A21-B175-6769012CF487}" dt="2026-04-14T07:35:42.301" v="1510" actId="790"/>
+          <ac:chgData name="Virve Räni" userId="161a7437-7ef4-49ec-91bf-54882f313dfe" providerId="ADAL" clId="{6D754EED-65AA-4A21-B175-6769012CF487}" dt="2026-04-15T10:12:18.229" v="2098" actId="790"/>
           <ac:spMkLst>
             <pc:docMk/>
             <pc:sldMk cId="1505008034" sldId="502"/>
@@ -603,7 +613,7 @@
           </ac:spMkLst>
         </pc:spChg>
         <pc:spChg chg="mod">
-          <ac:chgData name="Virve Räni" userId="161a7437-7ef4-49ec-91bf-54882f313dfe" providerId="ADAL" clId="{6D754EED-65AA-4A21-B175-6769012CF487}" dt="2026-04-14T07:35:42.301" v="1510" actId="790"/>
+          <ac:chgData name="Virve Räni" userId="161a7437-7ef4-49ec-91bf-54882f313dfe" providerId="ADAL" clId="{6D754EED-65AA-4A21-B175-6769012CF487}" dt="2026-04-15T10:12:18.229" v="2098" actId="790"/>
           <ac:spMkLst>
             <pc:docMk/>
             <pc:sldMk cId="1505008034" sldId="502"/>
@@ -611,7 +621,7 @@
           </ac:spMkLst>
         </pc:spChg>
         <pc:spChg chg="mod">
-          <ac:chgData name="Virve Räni" userId="161a7437-7ef4-49ec-91bf-54882f313dfe" providerId="ADAL" clId="{6D754EED-65AA-4A21-B175-6769012CF487}" dt="2026-04-14T07:35:42.301" v="1510" actId="790"/>
+          <ac:chgData name="Virve Räni" userId="161a7437-7ef4-49ec-91bf-54882f313dfe" providerId="ADAL" clId="{6D754EED-65AA-4A21-B175-6769012CF487}" dt="2026-04-15T10:12:18.229" v="2098" actId="790"/>
           <ac:spMkLst>
             <pc:docMk/>
             <pc:sldMk cId="1505008034" sldId="502"/>
@@ -619,7 +629,7 @@
           </ac:spMkLst>
         </pc:spChg>
         <pc:graphicFrameChg chg="modGraphic">
-          <ac:chgData name="Virve Räni" userId="161a7437-7ef4-49ec-91bf-54882f313dfe" providerId="ADAL" clId="{6D754EED-65AA-4A21-B175-6769012CF487}" dt="2026-04-14T07:35:42.301" v="1510" actId="790"/>
+          <ac:chgData name="Virve Räni" userId="161a7437-7ef4-49ec-91bf-54882f313dfe" providerId="ADAL" clId="{6D754EED-65AA-4A21-B175-6769012CF487}" dt="2026-04-15T10:12:18.229" v="2098" actId="790"/>
           <ac:graphicFrameMkLst>
             <pc:docMk/>
             <pc:sldMk cId="1505008034" sldId="502"/>
@@ -628,13 +638,13 @@
         </pc:graphicFrameChg>
       </pc:sldChg>
       <pc:sldChg chg="modSp mod">
-        <pc:chgData name="Virve Räni" userId="161a7437-7ef4-49ec-91bf-54882f313dfe" providerId="ADAL" clId="{6D754EED-65AA-4A21-B175-6769012CF487}" dt="2026-04-14T07:35:42.301" v="1510" actId="790"/>
+        <pc:chgData name="Virve Räni" userId="161a7437-7ef4-49ec-91bf-54882f313dfe" providerId="ADAL" clId="{6D754EED-65AA-4A21-B175-6769012CF487}" dt="2026-04-15T10:12:18.229" v="2098" actId="790"/>
         <pc:sldMkLst>
           <pc:docMk/>
           <pc:sldMk cId="3055350471" sldId="509"/>
         </pc:sldMkLst>
         <pc:spChg chg="mod">
-          <ac:chgData name="Virve Räni" userId="161a7437-7ef4-49ec-91bf-54882f313dfe" providerId="ADAL" clId="{6D754EED-65AA-4A21-B175-6769012CF487}" dt="2026-04-14T07:35:42.301" v="1510" actId="790"/>
+          <ac:chgData name="Virve Räni" userId="161a7437-7ef4-49ec-91bf-54882f313dfe" providerId="ADAL" clId="{6D754EED-65AA-4A21-B175-6769012CF487}" dt="2026-04-15T10:12:18.229" v="2098" actId="790"/>
           <ac:spMkLst>
             <pc:docMk/>
             <pc:sldMk cId="3055350471" sldId="509"/>
@@ -642,7 +652,7 @@
           </ac:spMkLst>
         </pc:spChg>
         <pc:spChg chg="mod">
-          <ac:chgData name="Virve Räni" userId="161a7437-7ef4-49ec-91bf-54882f313dfe" providerId="ADAL" clId="{6D754EED-65AA-4A21-B175-6769012CF487}" dt="2026-04-14T07:35:42.301" v="1510" actId="790"/>
+          <ac:chgData name="Virve Räni" userId="161a7437-7ef4-49ec-91bf-54882f313dfe" providerId="ADAL" clId="{6D754EED-65AA-4A21-B175-6769012CF487}" dt="2026-04-15T10:12:18.229" v="2098" actId="790"/>
           <ac:spMkLst>
             <pc:docMk/>
             <pc:sldMk cId="3055350471" sldId="509"/>
@@ -650,7 +660,7 @@
           </ac:spMkLst>
         </pc:spChg>
         <pc:spChg chg="mod">
-          <ac:chgData name="Virve Räni" userId="161a7437-7ef4-49ec-91bf-54882f313dfe" providerId="ADAL" clId="{6D754EED-65AA-4A21-B175-6769012CF487}" dt="2026-04-14T07:35:42.301" v="1510" actId="790"/>
+          <ac:chgData name="Virve Räni" userId="161a7437-7ef4-49ec-91bf-54882f313dfe" providerId="ADAL" clId="{6D754EED-65AA-4A21-B175-6769012CF487}" dt="2026-04-15T10:12:18.229" v="2098" actId="790"/>
           <ac:spMkLst>
             <pc:docMk/>
             <pc:sldMk cId="3055350471" sldId="509"/>
@@ -659,13 +669,13 @@
         </pc:spChg>
       </pc:sldChg>
       <pc:sldChg chg="modSp mod">
-        <pc:chgData name="Virve Räni" userId="161a7437-7ef4-49ec-91bf-54882f313dfe" providerId="ADAL" clId="{6D754EED-65AA-4A21-B175-6769012CF487}" dt="2026-04-14T07:35:42.301" v="1510" actId="790"/>
+        <pc:chgData name="Virve Räni" userId="161a7437-7ef4-49ec-91bf-54882f313dfe" providerId="ADAL" clId="{6D754EED-65AA-4A21-B175-6769012CF487}" dt="2026-04-15T10:12:18.229" v="2098" actId="790"/>
         <pc:sldMkLst>
           <pc:docMk/>
           <pc:sldMk cId="3468310050" sldId="510"/>
         </pc:sldMkLst>
         <pc:spChg chg="mod">
-          <ac:chgData name="Virve Räni" userId="161a7437-7ef4-49ec-91bf-54882f313dfe" providerId="ADAL" clId="{6D754EED-65AA-4A21-B175-6769012CF487}" dt="2026-04-14T07:35:42.301" v="1510" actId="790"/>
+          <ac:chgData name="Virve Räni" userId="161a7437-7ef4-49ec-91bf-54882f313dfe" providerId="ADAL" clId="{6D754EED-65AA-4A21-B175-6769012CF487}" dt="2026-04-15T10:12:18.229" v="2098" actId="790"/>
           <ac:spMkLst>
             <pc:docMk/>
             <pc:sldMk cId="3468310050" sldId="510"/>
@@ -673,7 +683,7 @@
           </ac:spMkLst>
         </pc:spChg>
         <pc:spChg chg="mod">
-          <ac:chgData name="Virve Räni" userId="161a7437-7ef4-49ec-91bf-54882f313dfe" providerId="ADAL" clId="{6D754EED-65AA-4A21-B175-6769012CF487}" dt="2026-04-14T07:35:42.301" v="1510" actId="790"/>
+          <ac:chgData name="Virve Räni" userId="161a7437-7ef4-49ec-91bf-54882f313dfe" providerId="ADAL" clId="{6D754EED-65AA-4A21-B175-6769012CF487}" dt="2026-04-15T10:12:18.229" v="2098" actId="790"/>
           <ac:spMkLst>
             <pc:docMk/>
             <pc:sldMk cId="3468310050" sldId="510"/>
@@ -682,13 +692,13 @@
         </pc:spChg>
       </pc:sldChg>
       <pc:sldChg chg="modSp mod ord">
-        <pc:chgData name="Virve Räni" userId="161a7437-7ef4-49ec-91bf-54882f313dfe" providerId="ADAL" clId="{6D754EED-65AA-4A21-B175-6769012CF487}" dt="2026-04-14T07:35:42.301" v="1510" actId="790"/>
+        <pc:chgData name="Virve Räni" userId="161a7437-7ef4-49ec-91bf-54882f313dfe" providerId="ADAL" clId="{6D754EED-65AA-4A21-B175-6769012CF487}" dt="2026-04-15T10:12:18.229" v="2098" actId="790"/>
         <pc:sldMkLst>
           <pc:docMk/>
           <pc:sldMk cId="3284150055" sldId="561"/>
         </pc:sldMkLst>
         <pc:spChg chg="mod">
-          <ac:chgData name="Virve Räni" userId="161a7437-7ef4-49ec-91bf-54882f313dfe" providerId="ADAL" clId="{6D754EED-65AA-4A21-B175-6769012CF487}" dt="2026-04-14T07:35:42.301" v="1510" actId="790"/>
+          <ac:chgData name="Virve Räni" userId="161a7437-7ef4-49ec-91bf-54882f313dfe" providerId="ADAL" clId="{6D754EED-65AA-4A21-B175-6769012CF487}" dt="2026-04-15T10:12:18.229" v="2098" actId="790"/>
           <ac:spMkLst>
             <pc:docMk/>
             <pc:sldMk cId="3284150055" sldId="561"/>
@@ -696,7 +706,7 @@
           </ac:spMkLst>
         </pc:spChg>
         <pc:spChg chg="mod">
-          <ac:chgData name="Virve Räni" userId="161a7437-7ef4-49ec-91bf-54882f313dfe" providerId="ADAL" clId="{6D754EED-65AA-4A21-B175-6769012CF487}" dt="2026-04-14T07:35:42.301" v="1510" actId="790"/>
+          <ac:chgData name="Virve Räni" userId="161a7437-7ef4-49ec-91bf-54882f313dfe" providerId="ADAL" clId="{6D754EED-65AA-4A21-B175-6769012CF487}" dt="2026-04-15T10:12:18.229" v="2098" actId="790"/>
           <ac:spMkLst>
             <pc:docMk/>
             <pc:sldMk cId="3284150055" sldId="561"/>
@@ -705,13 +715,13 @@
         </pc:spChg>
       </pc:sldChg>
       <pc:sldChg chg="modSp mod ord">
-        <pc:chgData name="Virve Räni" userId="161a7437-7ef4-49ec-91bf-54882f313dfe" providerId="ADAL" clId="{6D754EED-65AA-4A21-B175-6769012CF487}" dt="2026-04-14T07:35:42.301" v="1510" actId="790"/>
+        <pc:chgData name="Virve Räni" userId="161a7437-7ef4-49ec-91bf-54882f313dfe" providerId="ADAL" clId="{6D754EED-65AA-4A21-B175-6769012CF487}" dt="2026-04-15T10:12:18.229" v="2098" actId="790"/>
         <pc:sldMkLst>
           <pc:docMk/>
           <pc:sldMk cId="3129493901" sldId="562"/>
         </pc:sldMkLst>
         <pc:spChg chg="mod">
-          <ac:chgData name="Virve Räni" userId="161a7437-7ef4-49ec-91bf-54882f313dfe" providerId="ADAL" clId="{6D754EED-65AA-4A21-B175-6769012CF487}" dt="2026-04-14T07:35:42.301" v="1510" actId="790"/>
+          <ac:chgData name="Virve Räni" userId="161a7437-7ef4-49ec-91bf-54882f313dfe" providerId="ADAL" clId="{6D754EED-65AA-4A21-B175-6769012CF487}" dt="2026-04-15T10:12:18.229" v="2098" actId="790"/>
           <ac:spMkLst>
             <pc:docMk/>
             <pc:sldMk cId="3129493901" sldId="562"/>
@@ -719,7 +729,7 @@
           </ac:spMkLst>
         </pc:spChg>
         <pc:spChg chg="mod">
-          <ac:chgData name="Virve Räni" userId="161a7437-7ef4-49ec-91bf-54882f313dfe" providerId="ADAL" clId="{6D754EED-65AA-4A21-B175-6769012CF487}" dt="2026-04-14T07:35:42.301" v="1510" actId="790"/>
+          <ac:chgData name="Virve Räni" userId="161a7437-7ef4-49ec-91bf-54882f313dfe" providerId="ADAL" clId="{6D754EED-65AA-4A21-B175-6769012CF487}" dt="2026-04-15T10:12:18.229" v="2098" actId="790"/>
           <ac:spMkLst>
             <pc:docMk/>
             <pc:sldMk cId="3129493901" sldId="562"/>
@@ -727,14 +737,37 @@
           </ac:spMkLst>
         </pc:spChg>
       </pc:sldChg>
+      <pc:sldChg chg="modSp add mod">
+        <pc:chgData name="Virve Räni" userId="161a7437-7ef4-49ec-91bf-54882f313dfe" providerId="ADAL" clId="{6D754EED-65AA-4A21-B175-6769012CF487}" dt="2026-04-15T10:12:18.229" v="2098" actId="790"/>
+        <pc:sldMkLst>
+          <pc:docMk/>
+          <pc:sldMk cId="645017635" sldId="574"/>
+        </pc:sldMkLst>
+        <pc:spChg chg="mod">
+          <ac:chgData name="Virve Räni" userId="161a7437-7ef4-49ec-91bf-54882f313dfe" providerId="ADAL" clId="{6D754EED-65AA-4A21-B175-6769012CF487}" dt="2026-04-15T10:12:18.229" v="2098" actId="790"/>
+          <ac:spMkLst>
+            <pc:docMk/>
+            <pc:sldMk cId="645017635" sldId="574"/>
+            <ac:spMk id="2" creationId="{D4725537-CB3E-C083-F8A7-F00B6AE12D6E}"/>
+          </ac:spMkLst>
+        </pc:spChg>
+        <pc:spChg chg="mod">
+          <ac:chgData name="Virve Räni" userId="161a7437-7ef4-49ec-91bf-54882f313dfe" providerId="ADAL" clId="{6D754EED-65AA-4A21-B175-6769012CF487}" dt="2026-04-15T10:12:18.229" v="2098" actId="790"/>
+          <ac:spMkLst>
+            <pc:docMk/>
+            <pc:sldMk cId="645017635" sldId="574"/>
+            <ac:spMk id="3" creationId="{721CFECB-31FC-C645-D35E-8C1758638C04}"/>
+          </ac:spMkLst>
+        </pc:spChg>
+      </pc:sldChg>
       <pc:sldChg chg="modSp mod">
-        <pc:chgData name="Virve Räni" userId="161a7437-7ef4-49ec-91bf-54882f313dfe" providerId="ADAL" clId="{6D754EED-65AA-4A21-B175-6769012CF487}" dt="2026-04-14T07:35:42.301" v="1510" actId="790"/>
+        <pc:chgData name="Virve Räni" userId="161a7437-7ef4-49ec-91bf-54882f313dfe" providerId="ADAL" clId="{6D754EED-65AA-4A21-B175-6769012CF487}" dt="2026-04-15T10:12:18.229" v="2098" actId="790"/>
         <pc:sldMkLst>
           <pc:docMk/>
           <pc:sldMk cId="3671455624" sldId="613"/>
         </pc:sldMkLst>
         <pc:spChg chg="mod">
-          <ac:chgData name="Virve Räni" userId="161a7437-7ef4-49ec-91bf-54882f313dfe" providerId="ADAL" clId="{6D754EED-65AA-4A21-B175-6769012CF487}" dt="2026-04-14T07:35:42.301" v="1510" actId="790"/>
+          <ac:chgData name="Virve Räni" userId="161a7437-7ef4-49ec-91bf-54882f313dfe" providerId="ADAL" clId="{6D754EED-65AA-4A21-B175-6769012CF487}" dt="2026-04-15T10:12:18.229" v="2098" actId="790"/>
           <ac:spMkLst>
             <pc:docMk/>
             <pc:sldMk cId="3671455624" sldId="613"/>
@@ -742,7 +775,7 @@
           </ac:spMkLst>
         </pc:spChg>
         <pc:spChg chg="mod">
-          <ac:chgData name="Virve Räni" userId="161a7437-7ef4-49ec-91bf-54882f313dfe" providerId="ADAL" clId="{6D754EED-65AA-4A21-B175-6769012CF487}" dt="2026-04-14T07:35:42.301" v="1510" actId="790"/>
+          <ac:chgData name="Virve Räni" userId="161a7437-7ef4-49ec-91bf-54882f313dfe" providerId="ADAL" clId="{6D754EED-65AA-4A21-B175-6769012CF487}" dt="2026-04-15T10:12:18.229" v="2098" actId="790"/>
           <ac:spMkLst>
             <pc:docMk/>
             <pc:sldMk cId="3671455624" sldId="613"/>
@@ -751,13 +784,13 @@
         </pc:spChg>
       </pc:sldChg>
       <pc:sldChg chg="modSp mod ord">
-        <pc:chgData name="Virve Räni" userId="161a7437-7ef4-49ec-91bf-54882f313dfe" providerId="ADAL" clId="{6D754EED-65AA-4A21-B175-6769012CF487}" dt="2026-04-14T07:35:42.301" v="1510" actId="790"/>
+        <pc:chgData name="Virve Räni" userId="161a7437-7ef4-49ec-91bf-54882f313dfe" providerId="ADAL" clId="{6D754EED-65AA-4A21-B175-6769012CF487}" dt="2026-04-15T10:12:18.229" v="2098" actId="790"/>
         <pc:sldMkLst>
           <pc:docMk/>
           <pc:sldMk cId="892811100" sldId="621"/>
         </pc:sldMkLst>
         <pc:spChg chg="mod">
-          <ac:chgData name="Virve Räni" userId="161a7437-7ef4-49ec-91bf-54882f313dfe" providerId="ADAL" clId="{6D754EED-65AA-4A21-B175-6769012CF487}" dt="2026-04-14T07:35:42.301" v="1510" actId="790"/>
+          <ac:chgData name="Virve Räni" userId="161a7437-7ef4-49ec-91bf-54882f313dfe" providerId="ADAL" clId="{6D754EED-65AA-4A21-B175-6769012CF487}" dt="2026-04-15T10:12:18.229" v="2098" actId="790"/>
           <ac:spMkLst>
             <pc:docMk/>
             <pc:sldMk cId="892811100" sldId="621"/>
@@ -765,7 +798,7 @@
           </ac:spMkLst>
         </pc:spChg>
         <pc:spChg chg="mod">
-          <ac:chgData name="Virve Räni" userId="161a7437-7ef4-49ec-91bf-54882f313dfe" providerId="ADAL" clId="{6D754EED-65AA-4A21-B175-6769012CF487}" dt="2026-04-14T07:35:42.301" v="1510" actId="790"/>
+          <ac:chgData name="Virve Räni" userId="161a7437-7ef4-49ec-91bf-54882f313dfe" providerId="ADAL" clId="{6D754EED-65AA-4A21-B175-6769012CF487}" dt="2026-04-15T10:12:18.229" v="2098" actId="790"/>
           <ac:spMkLst>
             <pc:docMk/>
             <pc:sldMk cId="892811100" sldId="621"/>
@@ -774,53 +807,21 @@
         </pc:spChg>
       </pc:sldChg>
       <pc:sldChg chg="addSp delSp modSp new mod">
-        <pc:chgData name="Virve Räni" userId="161a7437-7ef4-49ec-91bf-54882f313dfe" providerId="ADAL" clId="{6D754EED-65AA-4A21-B175-6769012CF487}" dt="2026-04-14T07:35:42.301" v="1510" actId="790"/>
+        <pc:chgData name="Virve Räni" userId="161a7437-7ef4-49ec-91bf-54882f313dfe" providerId="ADAL" clId="{6D754EED-65AA-4A21-B175-6769012CF487}" dt="2026-04-15T10:12:18.229" v="2098" actId="790"/>
         <pc:sldMkLst>
           <pc:docMk/>
           <pc:sldMk cId="2424721111" sldId="622"/>
         </pc:sldMkLst>
         <pc:spChg chg="mod">
-          <ac:chgData name="Virve Räni" userId="161a7437-7ef4-49ec-91bf-54882f313dfe" providerId="ADAL" clId="{6D754EED-65AA-4A21-B175-6769012CF487}" dt="2026-04-14T07:35:42.301" v="1510" actId="790"/>
+          <ac:chgData name="Virve Räni" userId="161a7437-7ef4-49ec-91bf-54882f313dfe" providerId="ADAL" clId="{6D754EED-65AA-4A21-B175-6769012CF487}" dt="2026-04-15T10:12:18.229" v="2098" actId="790"/>
           <ac:spMkLst>
             <pc:docMk/>
             <pc:sldMk cId="2424721111" sldId="622"/>
             <ac:spMk id="2" creationId="{01BDB4B1-9527-1475-535E-9F9EA27407A8}"/>
           </ac:spMkLst>
         </pc:spChg>
-        <pc:spChg chg="del">
-          <ac:chgData name="Virve Räni" userId="161a7437-7ef4-49ec-91bf-54882f313dfe" providerId="ADAL" clId="{6D754EED-65AA-4A21-B175-6769012CF487}" dt="2026-04-13T12:29:01.454" v="166" actId="931"/>
-          <ac:spMkLst>
-            <pc:docMk/>
-            <pc:sldMk cId="2424721111" sldId="622"/>
-            <ac:spMk id="3" creationId="{9A4D9829-4592-F048-13EB-AF058CFC73E2}"/>
-          </ac:spMkLst>
-        </pc:spChg>
-        <pc:spChg chg="add">
-          <ac:chgData name="Virve Räni" userId="161a7437-7ef4-49ec-91bf-54882f313dfe" providerId="ADAL" clId="{6D754EED-65AA-4A21-B175-6769012CF487}" dt="2026-04-13T12:28:27.429" v="165"/>
-          <ac:spMkLst>
-            <pc:docMk/>
-            <pc:sldMk cId="2424721111" sldId="622"/>
-            <ac:spMk id="6" creationId="{6E8F66AB-30A2-F51F-4880-10E3686F56FD}"/>
-          </ac:spMkLst>
-        </pc:spChg>
-        <pc:spChg chg="add">
-          <ac:chgData name="Virve Räni" userId="161a7437-7ef4-49ec-91bf-54882f313dfe" providerId="ADAL" clId="{6D754EED-65AA-4A21-B175-6769012CF487}" dt="2026-04-13T12:28:27.429" v="165"/>
-          <ac:spMkLst>
-            <pc:docMk/>
-            <pc:sldMk cId="2424721111" sldId="622"/>
-            <ac:spMk id="7" creationId="{1FA24C98-1BEC-9297-EC8F-F021F30080BA}"/>
-          </ac:spMkLst>
-        </pc:spChg>
-        <pc:spChg chg="add">
-          <ac:chgData name="Virve Räni" userId="161a7437-7ef4-49ec-91bf-54882f313dfe" providerId="ADAL" clId="{6D754EED-65AA-4A21-B175-6769012CF487}" dt="2026-04-13T12:28:27.429" v="165"/>
-          <ac:spMkLst>
-            <pc:docMk/>
-            <pc:sldMk cId="2424721111" sldId="622"/>
-            <ac:spMk id="8" creationId="{A373B9A5-B3ED-D43B-B03C-544854B64AE3}"/>
-          </ac:spMkLst>
-        </pc:spChg>
         <pc:spChg chg="add mod">
-          <ac:chgData name="Virve Räni" userId="161a7437-7ef4-49ec-91bf-54882f313dfe" providerId="ADAL" clId="{6D754EED-65AA-4A21-B175-6769012CF487}" dt="2026-04-14T07:35:42.301" v="1510" actId="790"/>
+          <ac:chgData name="Virve Räni" userId="161a7437-7ef4-49ec-91bf-54882f313dfe" providerId="ADAL" clId="{6D754EED-65AA-4A21-B175-6769012CF487}" dt="2026-04-15T10:12:18.229" v="2098" actId="790"/>
           <ac:spMkLst>
             <pc:docMk/>
             <pc:sldMk cId="2424721111" sldId="622"/>
@@ -828,29 +829,13 @@
           </ac:spMkLst>
         </pc:spChg>
         <pc:spChg chg="add mod">
-          <ac:chgData name="Virve Räni" userId="161a7437-7ef4-49ec-91bf-54882f313dfe" providerId="ADAL" clId="{6D754EED-65AA-4A21-B175-6769012CF487}" dt="2026-04-14T07:35:42.301" v="1510" actId="790"/>
+          <ac:chgData name="Virve Räni" userId="161a7437-7ef4-49ec-91bf-54882f313dfe" providerId="ADAL" clId="{6D754EED-65AA-4A21-B175-6769012CF487}" dt="2026-04-15T10:12:18.229" v="2098" actId="790"/>
           <ac:spMkLst>
             <pc:docMk/>
             <pc:sldMk cId="2424721111" sldId="622"/>
             <ac:spMk id="16" creationId="{4516AF46-3745-C210-FEEB-DA3F5D4A883D}"/>
           </ac:spMkLst>
         </pc:spChg>
-        <pc:picChg chg="add">
-          <ac:chgData name="Virve Räni" userId="161a7437-7ef4-49ec-91bf-54882f313dfe" providerId="ADAL" clId="{6D754EED-65AA-4A21-B175-6769012CF487}" dt="2026-04-13T12:28:27.429" v="165"/>
-          <ac:picMkLst>
-            <pc:docMk/>
-            <pc:sldMk cId="2424721111" sldId="622"/>
-            <ac:picMk id="4" creationId="{84872CFE-7A14-F4EF-6E89-E83552F1D189}"/>
-          </ac:picMkLst>
-        </pc:picChg>
-        <pc:picChg chg="add">
-          <ac:chgData name="Virve Räni" userId="161a7437-7ef4-49ec-91bf-54882f313dfe" providerId="ADAL" clId="{6D754EED-65AA-4A21-B175-6769012CF487}" dt="2026-04-13T12:28:27.429" v="165"/>
-          <ac:picMkLst>
-            <pc:docMk/>
-            <pc:sldMk cId="2424721111" sldId="622"/>
-            <ac:picMk id="5" creationId="{F1C605F8-3D7D-8606-6CA7-4E6B2B3DAB60}"/>
-          </ac:picMkLst>
-        </pc:picChg>
         <pc:picChg chg="add mod">
           <ac:chgData name="Virve Räni" userId="161a7437-7ef4-49ec-91bf-54882f313dfe" providerId="ADAL" clId="{6D754EED-65AA-4A21-B175-6769012CF487}" dt="2026-04-14T06:05:53.067" v="484" actId="1076"/>
           <ac:picMkLst>
@@ -877,13 +862,13 @@
         </pc:cxnChg>
       </pc:sldChg>
       <pc:sldChg chg="modSp add mod ord">
-        <pc:chgData name="Virve Räni" userId="161a7437-7ef4-49ec-91bf-54882f313dfe" providerId="ADAL" clId="{6D754EED-65AA-4A21-B175-6769012CF487}" dt="2026-04-14T07:35:42.301" v="1510" actId="790"/>
+        <pc:chgData name="Virve Räni" userId="161a7437-7ef4-49ec-91bf-54882f313dfe" providerId="ADAL" clId="{6D754EED-65AA-4A21-B175-6769012CF487}" dt="2026-04-15T10:12:18.229" v="2098" actId="790"/>
         <pc:sldMkLst>
           <pc:docMk/>
           <pc:sldMk cId="569809018" sldId="647"/>
         </pc:sldMkLst>
         <pc:spChg chg="mod">
-          <ac:chgData name="Virve Räni" userId="161a7437-7ef4-49ec-91bf-54882f313dfe" providerId="ADAL" clId="{6D754EED-65AA-4A21-B175-6769012CF487}" dt="2026-04-14T07:35:42.301" v="1510" actId="790"/>
+          <ac:chgData name="Virve Räni" userId="161a7437-7ef4-49ec-91bf-54882f313dfe" providerId="ADAL" clId="{6D754EED-65AA-4A21-B175-6769012CF487}" dt="2026-04-15T10:12:18.229" v="2098" actId="790"/>
           <ac:spMkLst>
             <pc:docMk/>
             <pc:sldMk cId="569809018" sldId="647"/>
@@ -891,7 +876,7 @@
           </ac:spMkLst>
         </pc:spChg>
         <pc:spChg chg="mod">
-          <ac:chgData name="Virve Räni" userId="161a7437-7ef4-49ec-91bf-54882f313dfe" providerId="ADAL" clId="{6D754EED-65AA-4A21-B175-6769012CF487}" dt="2026-04-14T07:35:42.301" v="1510" actId="790"/>
+          <ac:chgData name="Virve Räni" userId="161a7437-7ef4-49ec-91bf-54882f313dfe" providerId="ADAL" clId="{6D754EED-65AA-4A21-B175-6769012CF487}" dt="2026-04-15T10:12:18.229" v="2098" actId="790"/>
           <ac:spMkLst>
             <pc:docMk/>
             <pc:sldMk cId="569809018" sldId="647"/>
@@ -899,7 +884,7 @@
           </ac:spMkLst>
         </pc:spChg>
         <pc:spChg chg="mod">
-          <ac:chgData name="Virve Räni" userId="161a7437-7ef4-49ec-91bf-54882f313dfe" providerId="ADAL" clId="{6D754EED-65AA-4A21-B175-6769012CF487}" dt="2026-04-14T07:35:42.301" v="1510" actId="790"/>
+          <ac:chgData name="Virve Räni" userId="161a7437-7ef4-49ec-91bf-54882f313dfe" providerId="ADAL" clId="{6D754EED-65AA-4A21-B175-6769012CF487}" dt="2026-04-15T10:12:18.229" v="2098" actId="790"/>
           <ac:spMkLst>
             <pc:docMk/>
             <pc:sldMk cId="569809018" sldId="647"/>
@@ -907,7 +892,7 @@
           </ac:spMkLst>
         </pc:spChg>
         <pc:spChg chg="mod">
-          <ac:chgData name="Virve Räni" userId="161a7437-7ef4-49ec-91bf-54882f313dfe" providerId="ADAL" clId="{6D754EED-65AA-4A21-B175-6769012CF487}" dt="2026-04-14T07:35:42.301" v="1510" actId="790"/>
+          <ac:chgData name="Virve Räni" userId="161a7437-7ef4-49ec-91bf-54882f313dfe" providerId="ADAL" clId="{6D754EED-65AA-4A21-B175-6769012CF487}" dt="2026-04-15T10:12:18.229" v="2098" actId="790"/>
           <ac:spMkLst>
             <pc:docMk/>
             <pc:sldMk cId="569809018" sldId="647"/>
@@ -915,7 +900,7 @@
           </ac:spMkLst>
         </pc:spChg>
         <pc:spChg chg="mod">
-          <ac:chgData name="Virve Räni" userId="161a7437-7ef4-49ec-91bf-54882f313dfe" providerId="ADAL" clId="{6D754EED-65AA-4A21-B175-6769012CF487}" dt="2026-04-14T07:35:42.301" v="1510" actId="790"/>
+          <ac:chgData name="Virve Räni" userId="161a7437-7ef4-49ec-91bf-54882f313dfe" providerId="ADAL" clId="{6D754EED-65AA-4A21-B175-6769012CF487}" dt="2026-04-15T10:12:18.229" v="2098" actId="790"/>
           <ac:spMkLst>
             <pc:docMk/>
             <pc:sldMk cId="569809018" sldId="647"/>
@@ -924,13 +909,13 @@
         </pc:spChg>
       </pc:sldChg>
       <pc:sldChg chg="modSp add mod">
-        <pc:chgData name="Virve Räni" userId="161a7437-7ef4-49ec-91bf-54882f313dfe" providerId="ADAL" clId="{6D754EED-65AA-4A21-B175-6769012CF487}" dt="2026-04-14T07:35:42.301" v="1510" actId="790"/>
+        <pc:chgData name="Virve Räni" userId="161a7437-7ef4-49ec-91bf-54882f313dfe" providerId="ADAL" clId="{6D754EED-65AA-4A21-B175-6769012CF487}" dt="2026-04-15T10:12:18.229" v="2098" actId="790"/>
         <pc:sldMkLst>
           <pc:docMk/>
           <pc:sldMk cId="2339573158" sldId="656"/>
         </pc:sldMkLst>
         <pc:spChg chg="mod">
-          <ac:chgData name="Virve Räni" userId="161a7437-7ef4-49ec-91bf-54882f313dfe" providerId="ADAL" clId="{6D754EED-65AA-4A21-B175-6769012CF487}" dt="2026-04-14T07:35:42.301" v="1510" actId="790"/>
+          <ac:chgData name="Virve Räni" userId="161a7437-7ef4-49ec-91bf-54882f313dfe" providerId="ADAL" clId="{6D754EED-65AA-4A21-B175-6769012CF487}" dt="2026-04-15T10:12:18.229" v="2098" actId="790"/>
           <ac:spMkLst>
             <pc:docMk/>
             <pc:sldMk cId="2339573158" sldId="656"/>
@@ -938,7 +923,7 @@
           </ac:spMkLst>
         </pc:spChg>
         <pc:spChg chg="mod">
-          <ac:chgData name="Virve Räni" userId="161a7437-7ef4-49ec-91bf-54882f313dfe" providerId="ADAL" clId="{6D754EED-65AA-4A21-B175-6769012CF487}" dt="2026-04-14T07:35:42.301" v="1510" actId="790"/>
+          <ac:chgData name="Virve Räni" userId="161a7437-7ef4-49ec-91bf-54882f313dfe" providerId="ADAL" clId="{6D754EED-65AA-4A21-B175-6769012CF487}" dt="2026-04-15T10:12:18.229" v="2098" actId="790"/>
           <ac:spMkLst>
             <pc:docMk/>
             <pc:sldMk cId="2339573158" sldId="656"/>
@@ -946,7 +931,7 @@
           </ac:spMkLst>
         </pc:spChg>
         <pc:graphicFrameChg chg="modGraphic">
-          <ac:chgData name="Virve Räni" userId="161a7437-7ef4-49ec-91bf-54882f313dfe" providerId="ADAL" clId="{6D754EED-65AA-4A21-B175-6769012CF487}" dt="2026-04-14T07:35:42.301" v="1510" actId="790"/>
+          <ac:chgData name="Virve Räni" userId="161a7437-7ef4-49ec-91bf-54882f313dfe" providerId="ADAL" clId="{6D754EED-65AA-4A21-B175-6769012CF487}" dt="2026-04-15T10:12:18.229" v="2098" actId="790"/>
           <ac:graphicFrameMkLst>
             <pc:docMk/>
             <pc:sldMk cId="2339573158" sldId="656"/>
@@ -977,13 +962,13 @@
         </pc:spChg>
       </pc:sldChg>
       <pc:sldChg chg="modSp new mod">
-        <pc:chgData name="Virve Räni" userId="161a7437-7ef4-49ec-91bf-54882f313dfe" providerId="ADAL" clId="{6D754EED-65AA-4A21-B175-6769012CF487}" dt="2026-04-14T07:35:42.301" v="1510" actId="790"/>
+        <pc:chgData name="Virve Räni" userId="161a7437-7ef4-49ec-91bf-54882f313dfe" providerId="ADAL" clId="{6D754EED-65AA-4A21-B175-6769012CF487}" dt="2026-04-15T10:12:18.229" v="2098" actId="790"/>
         <pc:sldMkLst>
           <pc:docMk/>
           <pc:sldMk cId="1956567439" sldId="657"/>
         </pc:sldMkLst>
         <pc:spChg chg="mod">
-          <ac:chgData name="Virve Räni" userId="161a7437-7ef4-49ec-91bf-54882f313dfe" providerId="ADAL" clId="{6D754EED-65AA-4A21-B175-6769012CF487}" dt="2026-04-14T07:35:42.301" v="1510" actId="790"/>
+          <ac:chgData name="Virve Räni" userId="161a7437-7ef4-49ec-91bf-54882f313dfe" providerId="ADAL" clId="{6D754EED-65AA-4A21-B175-6769012CF487}" dt="2026-04-15T10:12:18.229" v="2098" actId="790"/>
           <ac:spMkLst>
             <pc:docMk/>
             <pc:sldMk cId="1956567439" sldId="657"/>
@@ -991,7 +976,7 @@
           </ac:spMkLst>
         </pc:spChg>
         <pc:spChg chg="mod">
-          <ac:chgData name="Virve Räni" userId="161a7437-7ef4-49ec-91bf-54882f313dfe" providerId="ADAL" clId="{6D754EED-65AA-4A21-B175-6769012CF487}" dt="2026-04-14T07:35:42.301" v="1510" actId="790"/>
+          <ac:chgData name="Virve Räni" userId="161a7437-7ef4-49ec-91bf-54882f313dfe" providerId="ADAL" clId="{6D754EED-65AA-4A21-B175-6769012CF487}" dt="2026-04-15T10:12:18.229" v="2098" actId="790"/>
           <ac:spMkLst>
             <pc:docMk/>
             <pc:sldMk cId="1956567439" sldId="657"/>
@@ -1000,13 +985,13 @@
         </pc:spChg>
       </pc:sldChg>
       <pc:sldChg chg="addSp delSp modSp new mod">
-        <pc:chgData name="Virve Räni" userId="161a7437-7ef4-49ec-91bf-54882f313dfe" providerId="ADAL" clId="{6D754EED-65AA-4A21-B175-6769012CF487}" dt="2026-04-14T07:37:34.911" v="1683" actId="20577"/>
+        <pc:chgData name="Virve Räni" userId="161a7437-7ef4-49ec-91bf-54882f313dfe" providerId="ADAL" clId="{6D754EED-65AA-4A21-B175-6769012CF487}" dt="2026-04-15T10:12:18.229" v="2098" actId="790"/>
         <pc:sldMkLst>
           <pc:docMk/>
           <pc:sldMk cId="1417137373" sldId="658"/>
         </pc:sldMkLst>
         <pc:spChg chg="mod">
-          <ac:chgData name="Virve Räni" userId="161a7437-7ef4-49ec-91bf-54882f313dfe" providerId="ADAL" clId="{6D754EED-65AA-4A21-B175-6769012CF487}" dt="2026-04-14T07:35:42.301" v="1510" actId="790"/>
+          <ac:chgData name="Virve Räni" userId="161a7437-7ef4-49ec-91bf-54882f313dfe" providerId="ADAL" clId="{6D754EED-65AA-4A21-B175-6769012CF487}" dt="2026-04-15T10:12:18.229" v="2098" actId="790"/>
           <ac:spMkLst>
             <pc:docMk/>
             <pc:sldMk cId="1417137373" sldId="658"/>
@@ -1014,7 +999,7 @@
           </ac:spMkLst>
         </pc:spChg>
         <pc:spChg chg="add del mod">
-          <ac:chgData name="Virve Räni" userId="161a7437-7ef4-49ec-91bf-54882f313dfe" providerId="ADAL" clId="{6D754EED-65AA-4A21-B175-6769012CF487}" dt="2026-04-14T07:37:34.911" v="1683" actId="20577"/>
+          <ac:chgData name="Virve Räni" userId="161a7437-7ef4-49ec-91bf-54882f313dfe" providerId="ADAL" clId="{6D754EED-65AA-4A21-B175-6769012CF487}" dt="2026-04-15T10:12:18.229" v="2098" actId="790"/>
           <ac:spMkLst>
             <pc:docMk/>
             <pc:sldMk cId="1417137373" sldId="658"/>
@@ -1022,7 +1007,7 @@
           </ac:spMkLst>
         </pc:spChg>
         <pc:spChg chg="add del mod">
-          <ac:chgData name="Virve Räni" userId="161a7437-7ef4-49ec-91bf-54882f313dfe" providerId="ADAL" clId="{6D754EED-65AA-4A21-B175-6769012CF487}" dt="2026-04-14T07:35:42.301" v="1510" actId="790"/>
+          <ac:chgData name="Virve Räni" userId="161a7437-7ef4-49ec-91bf-54882f313dfe" providerId="ADAL" clId="{6D754EED-65AA-4A21-B175-6769012CF487}" dt="2026-04-15T10:12:18.229" v="2098" actId="790"/>
           <ac:spMkLst>
             <pc:docMk/>
             <pc:sldMk cId="1417137373" sldId="658"/>
@@ -1053,6 +1038,59 @@
             <ac:picMk id="8" creationId="{9296259A-BDDE-1E72-A40D-2CCAFBA10677}"/>
           </ac:picMkLst>
         </pc:picChg>
+      </pc:sldChg>
+      <pc:sldChg chg="new del">
+        <pc:chgData name="Virve Räni" userId="161a7437-7ef4-49ec-91bf-54882f313dfe" providerId="ADAL" clId="{6D754EED-65AA-4A21-B175-6769012CF487}" dt="2026-04-15T10:04:16.155" v="1697" actId="47"/>
+        <pc:sldMkLst>
+          <pc:docMk/>
+          <pc:sldMk cId="2902002965" sldId="659"/>
+        </pc:sldMkLst>
+      </pc:sldChg>
+      <pc:sldChg chg="modSp new mod">
+        <pc:chgData name="Virve Räni" userId="161a7437-7ef4-49ec-91bf-54882f313dfe" providerId="ADAL" clId="{6D754EED-65AA-4A21-B175-6769012CF487}" dt="2026-04-15T10:12:18.229" v="2098" actId="790"/>
+        <pc:sldMkLst>
+          <pc:docMk/>
+          <pc:sldMk cId="3428811917" sldId="659"/>
+        </pc:sldMkLst>
+        <pc:spChg chg="mod">
+          <ac:chgData name="Virve Räni" userId="161a7437-7ef4-49ec-91bf-54882f313dfe" providerId="ADAL" clId="{6D754EED-65AA-4A21-B175-6769012CF487}" dt="2026-04-15T10:12:18.229" v="2098" actId="790"/>
+          <ac:spMkLst>
+            <pc:docMk/>
+            <pc:sldMk cId="3428811917" sldId="659"/>
+            <ac:spMk id="2" creationId="{CD98CB92-3A86-0BA9-A0AB-33BE1C1DEBBC}"/>
+          </ac:spMkLst>
+        </pc:spChg>
+        <pc:spChg chg="mod">
+          <ac:chgData name="Virve Räni" userId="161a7437-7ef4-49ec-91bf-54882f313dfe" providerId="ADAL" clId="{6D754EED-65AA-4A21-B175-6769012CF487}" dt="2026-04-15T10:12:18.229" v="2098" actId="790"/>
+          <ac:spMkLst>
+            <pc:docMk/>
+            <pc:sldMk cId="3428811917" sldId="659"/>
+            <ac:spMk id="3" creationId="{7574EBEB-2DAD-CE5A-D9C4-804B7FFDEAFD}"/>
+          </ac:spMkLst>
+        </pc:spChg>
+      </pc:sldChg>
+      <pc:sldChg chg="modSp add mod">
+        <pc:chgData name="Virve Räni" userId="161a7437-7ef4-49ec-91bf-54882f313dfe" providerId="ADAL" clId="{6D754EED-65AA-4A21-B175-6769012CF487}" dt="2026-04-15T10:12:18.229" v="2098" actId="790"/>
+        <pc:sldMkLst>
+          <pc:docMk/>
+          <pc:sldMk cId="2003990942" sldId="660"/>
+        </pc:sldMkLst>
+        <pc:spChg chg="mod">
+          <ac:chgData name="Virve Räni" userId="161a7437-7ef4-49ec-91bf-54882f313dfe" providerId="ADAL" clId="{6D754EED-65AA-4A21-B175-6769012CF487}" dt="2026-04-15T10:12:18.229" v="2098" actId="790"/>
+          <ac:spMkLst>
+            <pc:docMk/>
+            <pc:sldMk cId="2003990942" sldId="660"/>
+            <ac:spMk id="2" creationId="{3025FD5A-6949-7AE2-465F-8F815CD0B51F}"/>
+          </ac:spMkLst>
+        </pc:spChg>
+        <pc:spChg chg="mod">
+          <ac:chgData name="Virve Räni" userId="161a7437-7ef4-49ec-91bf-54882f313dfe" providerId="ADAL" clId="{6D754EED-65AA-4A21-B175-6769012CF487}" dt="2026-04-15T10:12:18.229" v="2098" actId="790"/>
+          <ac:spMkLst>
+            <pc:docMk/>
+            <pc:sldMk cId="2003990942" sldId="660"/>
+            <ac:spMk id="3" creationId="{7676F691-0913-80C5-72FB-1220E70DB644}"/>
+          </ac:spMkLst>
+        </pc:spChg>
       </pc:sldChg>
       <pc:sldMasterChg chg="delSldLayout">
         <pc:chgData name="Virve Räni" userId="161a7437-7ef4-49ec-91bf-54882f313dfe" providerId="ADAL" clId="{6D754EED-65AA-4A21-B175-6769012CF487}" dt="2026-04-14T06:07:13.021" v="488" actId="47"/>
@@ -3764,7 +3802,7 @@
           <a:p>
             <a:fld id="{F9D2AD6E-DEDD-49A0-A4BE-7A081A9112DA}" type="datetimeFigureOut">
               <a:rPr lang="en-US" smtClean="0"/>
-              <a:t>4/14/2026</a:t>
+              <a:t>4/15/2026</a:t>
             </a:fld>
             <a:endParaRPr lang="en-US"/>
           </a:p>
@@ -3940,7 +3978,7 @@
           </a:lstStyle>
           <a:p>
             <a:fld id="{2AF9C1A6-4321-41FA-B001-4140F0E2457F}" type="datetimeFigureOut">
-              <a:t>14.04.2026</a:t>
+              <a:t>15.04.2026</a:t>
             </a:fld>
             <a:endParaRPr lang="en-US"/>
           </a:p>
@@ -6452,7 +6490,7 @@
           <a:p>
             <a:fld id="{46699514-027B-49BD-8B49-5054CA40ECF4}" type="slidenum">
               <a:rPr lang="et-EE" smtClean="0"/>
-              <a:t>25</a:t>
+              <a:t>28</a:t>
             </a:fld>
             <a:endParaRPr lang="et-EE"/>
           </a:p>
@@ -17598,7 +17636,7 @@
           <a:p>
             <a:fld id="{DE840A40-73C8-4048-8140-49F5D65BB431}" type="datetimeFigureOut">
               <a:rPr lang="et-EE" smtClean="0"/>
-              <a:t>14.04.2026</a:t>
+              <a:t>15.04.2026</a:t>
             </a:fld>
             <a:endParaRPr lang="et-EE"/>
           </a:p>
@@ -30365,7 +30403,7 @@
           <p:nvPr>
             <p:extLst>
               <p:ext uri="{D42A27DB-BD31-4B8C-83A1-F6EECF244321}">
-                <p14:modId xmlns:p14="http://schemas.microsoft.com/office/powerpoint/2010/main" val="1785330971"/>
+                <p14:modId xmlns:p14="http://schemas.microsoft.com/office/powerpoint/2010/main" val="1277544032"/>
               </p:ext>
             </p:extLst>
           </p:nvPr>
@@ -33522,7 +33560,7 @@
           <p:nvPr>
             <p:extLst>
               <p:ext uri="{D42A27DB-BD31-4B8C-83A1-F6EECF244321}">
-                <p14:modId xmlns:p14="http://schemas.microsoft.com/office/powerpoint/2010/main" val="3570201444"/>
+                <p14:modId xmlns:p14="http://schemas.microsoft.com/office/powerpoint/2010/main" val="3991708309"/>
               </p:ext>
             </p:extLst>
           </p:nvPr>
@@ -34841,7 +34879,7 @@
           <p:nvPr>
             <p:extLst>
               <p:ext uri="{D42A27DB-BD31-4B8C-83A1-F6EECF244321}">
-                <p14:modId xmlns:p14="http://schemas.microsoft.com/office/powerpoint/2010/main" val="4221310912"/>
+                <p14:modId xmlns:p14="http://schemas.microsoft.com/office/powerpoint/2010/main" val="490465038"/>
               </p:ext>
             </p:extLst>
           </p:nvPr>
@@ -35950,7 +35988,7 @@
             <p:ph sz="quarter" idx="10"/>
             <p:extLst>
               <p:ext uri="{D42A27DB-BD31-4B8C-83A1-F6EECF244321}">
-                <p14:modId xmlns:p14="http://schemas.microsoft.com/office/powerpoint/2010/main" val="1491393880"/>
+                <p14:modId xmlns:p14="http://schemas.microsoft.com/office/powerpoint/2010/main" val="365551876"/>
               </p:ext>
             </p:extLst>
           </p:nvPr>
@@ -36866,7 +36904,7 @@
           <p:nvPr>
             <p:extLst>
               <p:ext uri="{D42A27DB-BD31-4B8C-83A1-F6EECF244321}">
-                <p14:modId xmlns:p14="http://schemas.microsoft.com/office/powerpoint/2010/main" val="3987777690"/>
+                <p14:modId xmlns:p14="http://schemas.microsoft.com/office/powerpoint/2010/main" val="595961738"/>
               </p:ext>
             </p:extLst>
           </p:nvPr>
@@ -37215,6 +37253,688 @@
   <p:cSld>
     <p:spTree>
       <p:nvGrpSpPr>
+        <p:cNvPr id="1" name="">
+          <a:extLst>
+            <a:ext uri="{FF2B5EF4-FFF2-40B4-BE49-F238E27FC236}">
+              <a16:creationId xmlns:a16="http://schemas.microsoft.com/office/drawing/2014/main" id="{15FF916F-3A2C-85BA-9906-09B4A79C0272}"/>
+            </a:ext>
+          </a:extLst>
+        </p:cNvPr>
+        <p:cNvGrpSpPr/>
+        <p:nvPr/>
+      </p:nvGrpSpPr>
+      <p:grpSpPr>
+        <a:xfrm>
+          <a:off x="0" y="0"/>
+          <a:ext cx="0" cy="0"/>
+          <a:chOff x="0" y="0"/>
+          <a:chExt cx="0" cy="0"/>
+        </a:xfrm>
+      </p:grpSpPr>
+      <p:sp>
+        <p:nvSpPr>
+          <p:cNvPr id="2" name="Title 1">
+            <a:extLst>
+              <a:ext uri="{FF2B5EF4-FFF2-40B4-BE49-F238E27FC236}">
+                <a16:creationId xmlns:a16="http://schemas.microsoft.com/office/drawing/2014/main" id="{D4725537-CB3E-C083-F8A7-F00B6AE12D6E}"/>
+              </a:ext>
+            </a:extLst>
+          </p:cNvPr>
+          <p:cNvSpPr>
+            <a:spLocks noGrp="1"/>
+          </p:cNvSpPr>
+          <p:nvPr>
+            <p:ph type="ctrTitle"/>
+          </p:nvPr>
+        </p:nvSpPr>
+        <p:spPr>
+          <a:xfrm>
+            <a:off x="614923" y="479570"/>
+            <a:ext cx="10044112" cy="357043"/>
+          </a:xfrm>
+        </p:spPr>
+        <p:txBody>
+          <a:bodyPr/>
+          <a:lstStyle/>
+          <a:p>
+            <a:r>
+              <a:rPr lang="et-EE" b="1" noProof="0" dirty="0"/>
+              <a:t>Lõputöö osad</a:t>
+            </a:r>
+            <a:endParaRPr lang="et-EE" noProof="0" dirty="0"/>
+          </a:p>
+        </p:txBody>
+      </p:sp>
+      <p:sp>
+        <p:nvSpPr>
+          <p:cNvPr id="3" name="Content Placeholder 2">
+            <a:extLst>
+              <a:ext uri="{FF2B5EF4-FFF2-40B4-BE49-F238E27FC236}">
+                <a16:creationId xmlns:a16="http://schemas.microsoft.com/office/drawing/2014/main" id="{721CFECB-31FC-C645-D35E-8C1758638C04}"/>
+              </a:ext>
+            </a:extLst>
+          </p:cNvPr>
+          <p:cNvSpPr>
+            <a:spLocks noGrp="1"/>
+          </p:cNvSpPr>
+          <p:nvPr>
+            <p:ph sz="quarter" idx="10"/>
+          </p:nvPr>
+        </p:nvSpPr>
+        <p:spPr/>
+        <p:txBody>
+          <a:bodyPr/>
+          <a:lstStyle/>
+          <a:p>
+            <a:pPr marL="457200" indent="-457200">
+              <a:lnSpc>
+                <a:spcPct val="150000"/>
+              </a:lnSpc>
+              <a:buAutoNum type="arabicPeriod"/>
+            </a:pPr>
+            <a:r>
+              <a:rPr lang="et-EE" sz="2000" noProof="0" dirty="0">
+                <a:ea typeface="Inter"/>
+                <a:cs typeface="Noto Serif"/>
+              </a:rPr>
+              <a:t>Ettevõtte ja uurimisprobleemi tutvustus</a:t>
+            </a:r>
+            <a:endParaRPr lang="et-EE" sz="2000" noProof="0" dirty="0">
+              <a:cs typeface="Noto Serif"/>
+            </a:endParaRPr>
+          </a:p>
+          <a:p>
+            <a:pPr marL="457200" indent="-457200">
+              <a:lnSpc>
+                <a:spcPct val="150000"/>
+              </a:lnSpc>
+              <a:buClr>
+                <a:srgbClr val="121212"/>
+              </a:buClr>
+              <a:buAutoNum type="arabicPeriod"/>
+            </a:pPr>
+            <a:r>
+              <a:rPr lang="et-EE" sz="2000" noProof="0" dirty="0">
+                <a:ea typeface="Inter"/>
+                <a:cs typeface="Noto Serif"/>
+              </a:rPr>
+              <a:t>Uurimisplaan</a:t>
+            </a:r>
+            <a:endParaRPr lang="et-EE" sz="2000" noProof="0" dirty="0">
+              <a:cs typeface="Noto Serif"/>
+            </a:endParaRPr>
+          </a:p>
+          <a:p>
+            <a:pPr marL="457200" indent="-457200">
+              <a:lnSpc>
+                <a:spcPct val="150000"/>
+              </a:lnSpc>
+              <a:buClr>
+                <a:srgbClr val="121212"/>
+              </a:buClr>
+              <a:buAutoNum type="arabicPeriod"/>
+            </a:pPr>
+            <a:r>
+              <a:rPr lang="et-EE" sz="2000" noProof="0" dirty="0">
+                <a:ea typeface="Inter"/>
+                <a:cs typeface="Noto Serif"/>
+              </a:rPr>
+              <a:t>Andmekaitse kirjeldus – mis alustel andmeid töödeldakse?</a:t>
+            </a:r>
+            <a:endParaRPr lang="et-EE" sz="2000" noProof="0" dirty="0">
+              <a:cs typeface="Noto Serif"/>
+            </a:endParaRPr>
+          </a:p>
+          <a:p>
+            <a:pPr marL="457200" indent="-457200">
+              <a:lnSpc>
+                <a:spcPct val="150000"/>
+              </a:lnSpc>
+              <a:buClr>
+                <a:srgbClr val="121212"/>
+              </a:buClr>
+              <a:buAutoNum type="arabicPeriod"/>
+            </a:pPr>
+            <a:r>
+              <a:rPr lang="et-EE" sz="2000" noProof="0" dirty="0">
+                <a:ea typeface="Inter"/>
+                <a:cs typeface="Noto Serif"/>
+              </a:rPr>
+              <a:t>Ärisõnastik, andmemudel, andmesõnastik</a:t>
+            </a:r>
+            <a:endParaRPr lang="et-EE" sz="2000" noProof="0" dirty="0">
+              <a:cs typeface="Noto Serif"/>
+            </a:endParaRPr>
+          </a:p>
+          <a:p>
+            <a:pPr marL="457200" indent="-457200">
+              <a:lnSpc>
+                <a:spcPct val="150000"/>
+              </a:lnSpc>
+              <a:buClr>
+                <a:srgbClr val="121212"/>
+              </a:buClr>
+              <a:buAutoNum type="arabicPeriod"/>
+            </a:pPr>
+            <a:r>
+              <a:rPr lang="et-EE" sz="2000" noProof="0" dirty="0">
+                <a:ea typeface="Inter"/>
+                <a:cs typeface="Noto Serif"/>
+              </a:rPr>
+              <a:t>Andmevoog</a:t>
+            </a:r>
+            <a:endParaRPr lang="et-EE" sz="2000" noProof="0" dirty="0">
+              <a:cs typeface="Noto Serif"/>
+            </a:endParaRPr>
+          </a:p>
+          <a:p>
+            <a:pPr marL="457200" indent="-457200">
+              <a:lnSpc>
+                <a:spcPct val="150000"/>
+              </a:lnSpc>
+              <a:buClr>
+                <a:srgbClr val="121212"/>
+              </a:buClr>
+              <a:buAutoNum type="arabicPeriod"/>
+            </a:pPr>
+            <a:r>
+              <a:rPr lang="et-EE" sz="2000" noProof="0" dirty="0">
+                <a:ea typeface="Inter"/>
+                <a:cs typeface="Noto Serif"/>
+              </a:rPr>
+              <a:t>Näidisandmestiku loomine</a:t>
+            </a:r>
+            <a:endParaRPr lang="et-EE" sz="2000" noProof="0" dirty="0">
+              <a:cs typeface="Noto Serif"/>
+            </a:endParaRPr>
+          </a:p>
+          <a:p>
+            <a:pPr marL="457200" indent="-457200">
+              <a:lnSpc>
+                <a:spcPct val="150000"/>
+              </a:lnSpc>
+              <a:buClr>
+                <a:srgbClr val="121212"/>
+              </a:buClr>
+              <a:buAutoNum type="arabicPeriod"/>
+            </a:pPr>
+            <a:r>
+              <a:rPr lang="et-EE" sz="2000" noProof="0" dirty="0">
+                <a:ea typeface="Inter"/>
+                <a:cs typeface="Noto Serif"/>
+              </a:rPr>
+              <a:t>Andmete kvaliteedi kontroll</a:t>
+            </a:r>
+            <a:endParaRPr lang="et-EE" sz="2000" noProof="0" dirty="0">
+              <a:cs typeface="Noto Serif"/>
+            </a:endParaRPr>
+          </a:p>
+          <a:p>
+            <a:pPr marL="457200" indent="-457200">
+              <a:lnSpc>
+                <a:spcPct val="150000"/>
+              </a:lnSpc>
+              <a:buClr>
+                <a:srgbClr val="121212"/>
+              </a:buClr>
+              <a:buAutoNum type="arabicPeriod"/>
+            </a:pPr>
+            <a:r>
+              <a:rPr lang="et-EE" sz="2000" noProof="0" dirty="0">
+                <a:ea typeface="Inter"/>
+                <a:cs typeface="Noto Serif"/>
+              </a:rPr>
+              <a:t>Andmete </a:t>
+            </a:r>
+            <a:r>
+              <a:rPr lang="et-EE" sz="2000" noProof="0" dirty="0" err="1">
+                <a:ea typeface="Inter"/>
+                <a:cs typeface="Noto Serif"/>
+              </a:rPr>
+              <a:t>eksploratiivne</a:t>
+            </a:r>
+            <a:r>
+              <a:rPr lang="et-EE" sz="2000" noProof="0" dirty="0">
+                <a:ea typeface="Inter"/>
+                <a:cs typeface="Noto Serif"/>
+              </a:rPr>
+              <a:t> analüüs</a:t>
+            </a:r>
+            <a:endParaRPr lang="et-EE" sz="2000" noProof="0" dirty="0">
+              <a:cs typeface="Noto Serif"/>
+            </a:endParaRPr>
+          </a:p>
+          <a:p>
+            <a:pPr marL="457200" indent="-457200">
+              <a:lnSpc>
+                <a:spcPct val="150000"/>
+              </a:lnSpc>
+              <a:buClr>
+                <a:srgbClr val="121212"/>
+              </a:buClr>
+              <a:buAutoNum type="arabicPeriod"/>
+            </a:pPr>
+            <a:r>
+              <a:rPr lang="et-EE" sz="2000" noProof="0" dirty="0">
+                <a:ea typeface="Inter"/>
+                <a:cs typeface="Noto Serif"/>
+              </a:rPr>
+              <a:t>Andmete statistiline analüüs</a:t>
+            </a:r>
+            <a:endParaRPr lang="et-EE" sz="2000" noProof="0" dirty="0">
+              <a:cs typeface="Noto Serif"/>
+            </a:endParaRPr>
+          </a:p>
+          <a:p>
+            <a:pPr marL="457200" indent="-457200">
+              <a:lnSpc>
+                <a:spcPct val="150000"/>
+              </a:lnSpc>
+              <a:buClr>
+                <a:srgbClr val="121212"/>
+              </a:buClr>
+              <a:buAutoNum type="arabicPeriod"/>
+            </a:pPr>
+            <a:r>
+              <a:rPr lang="et-EE" sz="2000" noProof="0" dirty="0">
+                <a:ea typeface="Inter"/>
+                <a:cs typeface="Noto Serif"/>
+              </a:rPr>
+              <a:t>Kirjeldav raport / analüüs</a:t>
+            </a:r>
+            <a:endParaRPr lang="et-EE" sz="2000" noProof="0" dirty="0">
+              <a:cs typeface="Noto Serif"/>
+            </a:endParaRPr>
+          </a:p>
+          <a:p>
+            <a:pPr marL="457200" indent="-457200">
+              <a:lnSpc>
+                <a:spcPct val="150000"/>
+              </a:lnSpc>
+              <a:buClr>
+                <a:srgbClr val="121212"/>
+              </a:buClr>
+              <a:buAutoNum type="arabicPeriod"/>
+            </a:pPr>
+            <a:r>
+              <a:rPr lang="et-EE" sz="2000" noProof="0" dirty="0">
+                <a:ea typeface="Inter"/>
+                <a:cs typeface="Noto Serif"/>
+              </a:rPr>
+              <a:t>Andmelugu, järeldused</a:t>
+            </a:r>
+            <a:endParaRPr lang="et-EE" sz="2000" noProof="0" dirty="0">
+              <a:cs typeface="Noto Serif"/>
+            </a:endParaRPr>
+          </a:p>
+          <a:p>
+            <a:pPr marL="342900" indent="-342900">
+              <a:lnSpc>
+                <a:spcPct val="150000"/>
+              </a:lnSpc>
+              <a:buClr>
+                <a:srgbClr val="121212"/>
+              </a:buClr>
+              <a:buFont typeface="Inter" panose="020B0502030000000004" pitchFamily="34" charset="0"/>
+              <a:buAutoNum type="arabicPeriod"/>
+            </a:pPr>
+            <a:endParaRPr lang="et-EE" sz="2400" noProof="0" dirty="0">
+              <a:cs typeface="Noto Serif"/>
+            </a:endParaRPr>
+          </a:p>
+          <a:p>
+            <a:pPr marL="342900" indent="-342900">
+              <a:lnSpc>
+                <a:spcPct val="150000"/>
+              </a:lnSpc>
+              <a:buClr>
+                <a:srgbClr val="121212"/>
+              </a:buClr>
+              <a:buFont typeface="Inter" panose="020B0502030000000004" pitchFamily="34" charset="0"/>
+              <a:buAutoNum type="arabicPeriod"/>
+            </a:pPr>
+            <a:endParaRPr lang="et-EE" sz="2400" noProof="0" dirty="0">
+              <a:cs typeface="Arial"/>
+            </a:endParaRPr>
+          </a:p>
+          <a:p>
+            <a:pPr marL="857250" lvl="1" indent="-342900">
+              <a:lnSpc>
+                <a:spcPct val="150000"/>
+              </a:lnSpc>
+              <a:buFont typeface="Arial,Sans-Serif" panose="020B0502030000000004" pitchFamily="34" charset="0"/>
+              <a:buChar char="o"/>
+            </a:pPr>
+            <a:endParaRPr lang="et-EE" sz="2400" noProof="0" dirty="0">
+              <a:cs typeface="Arial"/>
+            </a:endParaRPr>
+          </a:p>
+          <a:p>
+            <a:pPr marL="342900" indent="-342900">
+              <a:lnSpc>
+                <a:spcPct val="150000"/>
+              </a:lnSpc>
+              <a:buAutoNum type="arabicPeriod"/>
+            </a:pPr>
+            <a:endParaRPr lang="et-EE" sz="2400" noProof="0" dirty="0">
+              <a:cs typeface="Arial"/>
+            </a:endParaRPr>
+          </a:p>
+          <a:p>
+            <a:pPr marL="514350" indent="-514350">
+              <a:lnSpc>
+                <a:spcPct val="150000"/>
+              </a:lnSpc>
+              <a:buAutoNum type="arabicPeriod"/>
+            </a:pPr>
+            <a:endParaRPr lang="et-EE" sz="2800" noProof="0" dirty="0">
+              <a:cs typeface="Arial"/>
+            </a:endParaRPr>
+          </a:p>
+          <a:p>
+            <a:pPr marL="0" indent="0">
+              <a:lnSpc>
+                <a:spcPct val="150000"/>
+              </a:lnSpc>
+              <a:buNone/>
+            </a:pPr>
+            <a:endParaRPr lang="et-EE" sz="2800" noProof="0" dirty="0"/>
+          </a:p>
+        </p:txBody>
+      </p:sp>
+    </p:spTree>
+    <p:extLst>
+      <p:ext uri="{BB962C8B-B14F-4D97-AF65-F5344CB8AC3E}">
+        <p14:creationId xmlns:p14="http://schemas.microsoft.com/office/powerpoint/2010/main" val="645017635"/>
+      </p:ext>
+    </p:extLst>
+  </p:cSld>
+  <p:clrMapOvr>
+    <a:masterClrMapping/>
+  </p:clrMapOvr>
+</p:sld>
+</file>
+
+<file path=ppt/slides/slide25.xml><?xml version="1.0" encoding="utf-8"?>
+<p:sld xmlns:a="http://schemas.openxmlformats.org/drawingml/2006/main" xmlns:r="http://schemas.openxmlformats.org/officeDocument/2006/relationships" xmlns:p="http://schemas.openxmlformats.org/presentationml/2006/main">
+  <p:cSld>
+    <p:spTree>
+      <p:nvGrpSpPr>
+        <p:cNvPr id="1" name=""/>
+        <p:cNvGrpSpPr/>
+        <p:nvPr/>
+      </p:nvGrpSpPr>
+      <p:grpSpPr>
+        <a:xfrm>
+          <a:off x="0" y="0"/>
+          <a:ext cx="0" cy="0"/>
+          <a:chOff x="0" y="0"/>
+          <a:chExt cx="0" cy="0"/>
+        </a:xfrm>
+      </p:grpSpPr>
+      <p:sp>
+        <p:nvSpPr>
+          <p:cNvPr id="2" name="Title 1">
+            <a:extLst>
+              <a:ext uri="{FF2B5EF4-FFF2-40B4-BE49-F238E27FC236}">
+                <a16:creationId xmlns:a16="http://schemas.microsoft.com/office/drawing/2014/main" id="{CD98CB92-3A86-0BA9-A0AB-33BE1C1DEBBC}"/>
+              </a:ext>
+            </a:extLst>
+          </p:cNvPr>
+          <p:cNvSpPr>
+            <a:spLocks noGrp="1"/>
+          </p:cNvSpPr>
+          <p:nvPr>
+            <p:ph type="ctrTitle"/>
+          </p:nvPr>
+        </p:nvSpPr>
+        <p:spPr/>
+        <p:txBody>
+          <a:bodyPr/>
+          <a:lstStyle/>
+          <a:p>
+            <a:r>
+              <a:rPr lang="et-EE" noProof="0" dirty="0"/>
+              <a:t>Lõputöö ajakava</a:t>
+            </a:r>
+          </a:p>
+        </p:txBody>
+      </p:sp>
+      <p:sp>
+        <p:nvSpPr>
+          <p:cNvPr id="3" name="Content Placeholder 2">
+            <a:extLst>
+              <a:ext uri="{FF2B5EF4-FFF2-40B4-BE49-F238E27FC236}">
+                <a16:creationId xmlns:a16="http://schemas.microsoft.com/office/drawing/2014/main" id="{7574EBEB-2DAD-CE5A-D9C4-804B7FFDEAFD}"/>
+              </a:ext>
+            </a:extLst>
+          </p:cNvPr>
+          <p:cNvSpPr>
+            <a:spLocks noGrp="1"/>
+          </p:cNvSpPr>
+          <p:nvPr>
+            <p:ph sz="quarter" idx="10"/>
+          </p:nvPr>
+        </p:nvSpPr>
+        <p:spPr/>
+        <p:txBody>
+          <a:bodyPr/>
+          <a:lstStyle/>
+          <a:p>
+            <a:pPr>
+              <a:lnSpc>
+                <a:spcPct val="150000"/>
+              </a:lnSpc>
+            </a:pPr>
+            <a:r>
+              <a:rPr lang="et-EE" sz="2800" noProof="0" dirty="0"/>
+              <a:t>Reede pärastlõunaks märkida end huvipakkuva teema juurde</a:t>
+            </a:r>
+          </a:p>
+          <a:p>
+            <a:pPr>
+              <a:lnSpc>
+                <a:spcPct val="150000"/>
+              </a:lnSpc>
+            </a:pPr>
+            <a:r>
+              <a:rPr lang="et-EE" sz="2800" noProof="0" dirty="0"/>
+              <a:t>Teisipäeval kohtumine kliendiga</a:t>
+            </a:r>
+          </a:p>
+        </p:txBody>
+      </p:sp>
+    </p:spTree>
+    <p:extLst>
+      <p:ext uri="{BB962C8B-B14F-4D97-AF65-F5344CB8AC3E}">
+        <p14:creationId xmlns:p14="http://schemas.microsoft.com/office/powerpoint/2010/main" val="3428811917"/>
+      </p:ext>
+    </p:extLst>
+  </p:cSld>
+  <p:clrMapOvr>
+    <a:masterClrMapping/>
+  </p:clrMapOvr>
+</p:sld>
+</file>
+
+<file path=ppt/slides/slide26.xml><?xml version="1.0" encoding="utf-8"?>
+<p:sld xmlns:a="http://schemas.openxmlformats.org/drawingml/2006/main" xmlns:r="http://schemas.openxmlformats.org/officeDocument/2006/relationships" xmlns:p="http://schemas.openxmlformats.org/presentationml/2006/main">
+  <p:cSld>
+    <p:spTree>
+      <p:nvGrpSpPr>
+        <p:cNvPr id="1" name="">
+          <a:extLst>
+            <a:ext uri="{FF2B5EF4-FFF2-40B4-BE49-F238E27FC236}">
+              <a16:creationId xmlns:a16="http://schemas.microsoft.com/office/drawing/2014/main" id="{960EA89E-884F-AC22-89E7-4F8E2D577784}"/>
+            </a:ext>
+          </a:extLst>
+        </p:cNvPr>
+        <p:cNvGrpSpPr/>
+        <p:nvPr/>
+      </p:nvGrpSpPr>
+      <p:grpSpPr>
+        <a:xfrm>
+          <a:off x="0" y="0"/>
+          <a:ext cx="0" cy="0"/>
+          <a:chOff x="0" y="0"/>
+          <a:chExt cx="0" cy="0"/>
+        </a:xfrm>
+      </p:grpSpPr>
+      <p:sp>
+        <p:nvSpPr>
+          <p:cNvPr id="2" name="Title 1">
+            <a:extLst>
+              <a:ext uri="{FF2B5EF4-FFF2-40B4-BE49-F238E27FC236}">
+                <a16:creationId xmlns:a16="http://schemas.microsoft.com/office/drawing/2014/main" id="{3025FD5A-6949-7AE2-465F-8F815CD0B51F}"/>
+              </a:ext>
+            </a:extLst>
+          </p:cNvPr>
+          <p:cNvSpPr>
+            <a:spLocks noGrp="1"/>
+          </p:cNvSpPr>
+          <p:nvPr>
+            <p:ph type="ctrTitle"/>
+          </p:nvPr>
+        </p:nvSpPr>
+        <p:spPr/>
+        <p:txBody>
+          <a:bodyPr/>
+          <a:lstStyle/>
+          <a:p>
+            <a:r>
+              <a:rPr lang="et-EE" noProof="0" dirty="0"/>
+              <a:t>Lõputöö soovitused</a:t>
+            </a:r>
+          </a:p>
+        </p:txBody>
+      </p:sp>
+      <p:sp>
+        <p:nvSpPr>
+          <p:cNvPr id="3" name="Content Placeholder 2">
+            <a:extLst>
+              <a:ext uri="{FF2B5EF4-FFF2-40B4-BE49-F238E27FC236}">
+                <a16:creationId xmlns:a16="http://schemas.microsoft.com/office/drawing/2014/main" id="{7676F691-0913-80C5-72FB-1220E70DB644}"/>
+              </a:ext>
+            </a:extLst>
+          </p:cNvPr>
+          <p:cNvSpPr>
+            <a:spLocks noGrp="1"/>
+          </p:cNvSpPr>
+          <p:nvPr>
+            <p:ph sz="quarter" idx="10"/>
+          </p:nvPr>
+        </p:nvSpPr>
+        <p:spPr/>
+        <p:txBody>
+          <a:bodyPr/>
+          <a:lstStyle/>
+          <a:p>
+            <a:pPr>
+              <a:lnSpc>
+                <a:spcPct val="150000"/>
+              </a:lnSpc>
+            </a:pPr>
+            <a:r>
+              <a:rPr lang="et-EE" sz="2400" noProof="0" dirty="0"/>
+              <a:t>Eraldi </a:t>
+            </a:r>
+            <a:r>
+              <a:rPr lang="et-EE" sz="2400" noProof="0" dirty="0" err="1"/>
+              <a:t>GitHub</a:t>
+            </a:r>
+            <a:r>
+              <a:rPr lang="et-EE" sz="2400" noProof="0" dirty="0"/>
+              <a:t> </a:t>
+            </a:r>
+            <a:r>
+              <a:rPr lang="et-EE" sz="2400" noProof="0" dirty="0" err="1"/>
+              <a:t>repository</a:t>
+            </a:r>
+            <a:endParaRPr lang="et-EE" sz="2400" noProof="0" dirty="0"/>
+          </a:p>
+          <a:p>
+            <a:pPr>
+              <a:lnSpc>
+                <a:spcPct val="150000"/>
+              </a:lnSpc>
+            </a:pPr>
+            <a:r>
+              <a:rPr lang="et-EE" sz="2400" noProof="0" dirty="0"/>
+              <a:t>Tiimi sees jagada rollid</a:t>
+            </a:r>
+          </a:p>
+          <a:p>
+            <a:pPr lvl="1">
+              <a:lnSpc>
+                <a:spcPct val="150000"/>
+              </a:lnSpc>
+            </a:pPr>
+            <a:r>
+              <a:rPr lang="et-EE" sz="2400" noProof="0" dirty="0"/>
+              <a:t>Projektijuht – vastutab, et asjad saaks õigeks ajaks tehtud</a:t>
+            </a:r>
+          </a:p>
+          <a:p>
+            <a:pPr lvl="1">
+              <a:lnSpc>
+                <a:spcPct val="150000"/>
+              </a:lnSpc>
+            </a:pPr>
+            <a:r>
+              <a:rPr lang="et-EE" sz="2400" noProof="0" dirty="0"/>
+              <a:t>Tootejuht – viimane sõna, kuidas asju teha</a:t>
+            </a:r>
+          </a:p>
+          <a:p>
+            <a:pPr>
+              <a:lnSpc>
+                <a:spcPct val="150000"/>
+              </a:lnSpc>
+            </a:pPr>
+            <a:r>
+              <a:rPr lang="et-EE" sz="2400" noProof="0" dirty="0"/>
+              <a:t>Igahommikune </a:t>
+            </a:r>
+            <a:r>
+              <a:rPr lang="et-EE" sz="2400" noProof="0" dirty="0" err="1"/>
+              <a:t>standup</a:t>
+            </a:r>
+            <a:r>
+              <a:rPr lang="et-EE" sz="2400" noProof="0" dirty="0"/>
+              <a:t> koosolek</a:t>
+            </a:r>
+          </a:p>
+          <a:p>
+            <a:pPr>
+              <a:lnSpc>
+                <a:spcPct val="150000"/>
+              </a:lnSpc>
+            </a:pPr>
+            <a:r>
+              <a:rPr lang="et-EE" sz="2400" noProof="0" dirty="0"/>
+              <a:t>Jagada ülesanded, nt README linnukestega nimekiri</a:t>
+            </a:r>
+          </a:p>
+        </p:txBody>
+      </p:sp>
+    </p:spTree>
+    <p:extLst>
+      <p:ext uri="{BB962C8B-B14F-4D97-AF65-F5344CB8AC3E}">
+        <p14:creationId xmlns:p14="http://schemas.microsoft.com/office/powerpoint/2010/main" val="2003990942"/>
+      </p:ext>
+    </p:extLst>
+  </p:cSld>
+  <p:clrMapOvr>
+    <a:masterClrMapping/>
+  </p:clrMapOvr>
+</p:sld>
+</file>
+
+<file path=ppt/slides/slide27.xml><?xml version="1.0" encoding="utf-8"?>
+<p:sld xmlns:a="http://schemas.openxmlformats.org/drawingml/2006/main" xmlns:r="http://schemas.openxmlformats.org/officeDocument/2006/relationships" xmlns:p="http://schemas.openxmlformats.org/presentationml/2006/main">
+  <p:cSld>
+    <p:spTree>
+      <p:nvGrpSpPr>
         <p:cNvPr id="1" name=""/>
         <p:cNvGrpSpPr/>
         <p:nvPr/>
@@ -37250,7 +37970,7 @@
           <a:p>
             <a:r>
               <a:rPr lang="et-EE" noProof="0" dirty="0"/>
-              <a:t>Grupitööde teemad</a:t>
+              <a:t>Lõputööde teemad</a:t>
             </a:r>
           </a:p>
         </p:txBody>
@@ -37339,7 +38059,7 @@
 </p:sld>
 </file>
 
-<file path=ppt/slides/slide25.xml><?xml version="1.0" encoding="utf-8"?>
+<file path=ppt/slides/slide28.xml><?xml version="1.0" encoding="utf-8"?>
 <p:sld xmlns:a="http://schemas.openxmlformats.org/drawingml/2006/main" xmlns:r="http://schemas.openxmlformats.org/officeDocument/2006/relationships" xmlns:p="http://schemas.openxmlformats.org/presentationml/2006/main">
   <p:cSld>
     <p:spTree>
@@ -37452,7 +38172,7 @@
 </p:sld>
 </file>
 
-<file path=ppt/slides/slide26.xml><?xml version="1.0" encoding="utf-8"?>
+<file path=ppt/slides/slide29.xml><?xml version="1.0" encoding="utf-8"?>
 <p:sld xmlns:a="http://schemas.openxmlformats.org/drawingml/2006/main" xmlns:r="http://schemas.openxmlformats.org/officeDocument/2006/relationships" xmlns:p="http://schemas.openxmlformats.org/presentationml/2006/main">
   <p:cSld>
     <p:spTree>
@@ -37528,25 +38248,16 @@
             </a:r>
             <a:r>
               <a:rPr lang="et-EE" sz="2000" noProof="0" dirty="0"/>
-              <a:t>-i</a:t>
-            </a:r>
-            <a:r>
-              <a:rPr lang="en-US" sz="2000" noProof="0" dirty="0"/>
-              <a:t>:</a:t>
-            </a:r>
-            <a:endParaRPr lang="en-US" sz="2000" dirty="0"/>
+              <a:t>-i:</a:t>
+            </a:r>
           </a:p>
           <a:p>
             <a:pPr marL="457200" lvl="1" indent="0">
               <a:buNone/>
             </a:pPr>
             <a:r>
-              <a:rPr lang="en-US" sz="2000" noProof="0" dirty="0"/>
-              <a:t>1) </a:t>
-            </a:r>
-            <a:r>
               <a:rPr lang="et-EE" sz="2000" noProof="0" dirty="0"/>
-              <a:t>Loome README profiili jaoks: </a:t>
+              <a:t>1) Loome README profiili jaoks: </a:t>
             </a:r>
           </a:p>
           <a:p>
@@ -37603,12 +38314,12 @@
             <a:endParaRPr lang="et-EE" noProof="0" dirty="0"/>
           </a:p>
           <a:p>
-            <a:endParaRPr lang="en-US" noProof="0" dirty="0"/>
+            <a:endParaRPr lang="et-EE" noProof="0" dirty="0"/>
           </a:p>
           <a:p>
             <a:pPr lvl="2"/>
             <a:r>
-              <a:rPr lang="en-US" dirty="0"/>
+              <a:rPr lang="et-EE" noProof="0" dirty="0"/>
               <a:t>Lisa README</a:t>
             </a:r>
           </a:p>
@@ -37623,16 +38334,8 @@
               <a:buNone/>
             </a:pPr>
             <a:r>
-              <a:rPr lang="en-US" sz="2000" noProof="0" dirty="0"/>
-              <a:t>2) </a:t>
-            </a:r>
-            <a:r>
-              <a:rPr lang="en-US" sz="2000" noProof="0" dirty="0" err="1"/>
-              <a:t>Täidame</a:t>
-            </a:r>
-            <a:r>
-              <a:rPr lang="en-US" sz="2000" noProof="0" dirty="0"/>
-              <a:t> README</a:t>
+              <a:rPr lang="et-EE" sz="2000" noProof="0" dirty="0"/>
+              <a:t>2) Täidame README</a:t>
             </a:r>
           </a:p>
           <a:p>
@@ -37640,24 +38343,16 @@
               <a:buNone/>
             </a:pPr>
             <a:r>
-              <a:rPr lang="en-US" sz="2000" dirty="0"/>
-              <a:t>3) </a:t>
-            </a:r>
-            <a:r>
-              <a:rPr lang="en-US" sz="2000" dirty="0" err="1"/>
-              <a:t>Täiendame</a:t>
-            </a:r>
-            <a:r>
-              <a:rPr lang="en-US" sz="2000" dirty="0"/>
-              <a:t> </a:t>
-            </a:r>
-            <a:r>
-              <a:rPr lang="en-US" sz="2000" dirty="0" err="1"/>
-              <a:t>Profiili</a:t>
-            </a:r>
-            <a:r>
-              <a:rPr lang="en-US" sz="2000" dirty="0"/>
-              <a:t>: Edit profile</a:t>
+              <a:rPr lang="et-EE" sz="2000" noProof="0" dirty="0"/>
+              <a:t>3) Täiendame Profiili: </a:t>
+            </a:r>
+            <a:r>
+              <a:rPr lang="et-EE" sz="2000" noProof="0" dirty="0" err="1"/>
+              <a:t>Edit</a:t>
+            </a:r>
+            <a:r>
+              <a:rPr lang="et-EE" sz="2000" noProof="0" dirty="0"/>
+              <a:t> profile</a:t>
             </a:r>
           </a:p>
           <a:p>
@@ -37665,42 +38360,17 @@
               <a:buNone/>
             </a:pPr>
             <a:r>
-              <a:rPr lang="en-US" sz="2000" noProof="0" dirty="0"/>
-              <a:t>4) </a:t>
-            </a:r>
-            <a:r>
-              <a:rPr lang="en-US" sz="2000" noProof="0" dirty="0" err="1"/>
-              <a:t>Valime</a:t>
-            </a:r>
-            <a:r>
-              <a:rPr lang="en-US" sz="2000" noProof="0" dirty="0"/>
-              <a:t> </a:t>
-            </a:r>
-            <a:r>
-              <a:rPr lang="en-US" sz="2000" dirty="0"/>
-              <a:t>repositories, </a:t>
-            </a:r>
-            <a:r>
-              <a:rPr lang="en-US" sz="2000" dirty="0" err="1"/>
-              <a:t>mida</a:t>
-            </a:r>
-            <a:r>
-              <a:rPr lang="en-US" sz="2000" dirty="0"/>
-              <a:t> </a:t>
-            </a:r>
-            <a:r>
-              <a:rPr lang="en-US" sz="2000" dirty="0" err="1"/>
-              <a:t>tahame</a:t>
-            </a:r>
-            <a:r>
-              <a:rPr lang="en-US" sz="2000" dirty="0"/>
-              <a:t> </a:t>
-            </a:r>
-            <a:r>
-              <a:rPr lang="en-US" sz="2000" dirty="0" err="1"/>
-              <a:t>näidata</a:t>
-            </a:r>
-            <a:endParaRPr lang="et-EE" sz="2000" noProof="0" dirty="0"/>
+              <a:rPr lang="et-EE" sz="2000" noProof="0" dirty="0"/>
+              <a:t>4) Valime </a:t>
+            </a:r>
+            <a:r>
+              <a:rPr lang="et-EE" sz="2000" noProof="0" dirty="0" err="1"/>
+              <a:t>repositories</a:t>
+            </a:r>
+            <a:r>
+              <a:rPr lang="et-EE" sz="2000" noProof="0" dirty="0"/>
+              <a:t>, mida tahame näidata</a:t>
+            </a:r>
           </a:p>
           <a:p>
             <a:pPr marL="0" indent="0">
@@ -39503,7 +40173,7 @@
             <p:ph sz="quarter" idx="10"/>
             <p:extLst>
               <p:ext uri="{D42A27DB-BD31-4B8C-83A1-F6EECF244321}">
-                <p14:modId xmlns:p14="http://schemas.microsoft.com/office/powerpoint/2010/main" val="1639342137"/>
+                <p14:modId xmlns:p14="http://schemas.microsoft.com/office/powerpoint/2010/main" val="1825501208"/>
               </p:ext>
             </p:extLst>
           </p:nvPr>
@@ -41422,21 +42092,12 @@
 </file>
 
 <file path=customXml/item1.xml><?xml version="1.0" encoding="utf-8"?>
-<?mso-contentType ?>
-<FormTemplates xmlns="http://schemas.microsoft.com/sharepoint/v3/contenttype/forms">
-  <Display>DocumentLibraryForm</Display>
-  <Edit>DocumentLibraryForm</Edit>
-  <New>DocumentLibraryForm</New>
-</FormTemplates>
-</file>
-
-<file path=customXml/item2.xml><?xml version="1.0" encoding="utf-8"?>
 <p:properties xmlns:p="http://schemas.microsoft.com/office/2006/metadata/properties" xmlns:xsi="http://www.w3.org/2001/XMLSchema-instance" xmlns:pc="http://schemas.microsoft.com/office/infopath/2007/PartnerControls">
   <documentManagement/>
 </p:properties>
 </file>
 
-<file path=customXml/item3.xml><?xml version="1.0" encoding="utf-8"?>
+<file path=customXml/item2.xml><?xml version="1.0" encoding="utf-8"?>
 <ct:contentTypeSchema xmlns:ct="http://schemas.microsoft.com/office/2006/metadata/contentType" xmlns:ma="http://schemas.microsoft.com/office/2006/metadata/properties/metaAttributes" ct:_="" ma:_="" ma:contentTypeName="Document" ma:contentTypeID="0x010100C4D27B8FA8976546BCD79313C588588D" ma:contentTypeVersion="8" ma:contentTypeDescription="Create a new document." ma:contentTypeScope="" ma:versionID="a112c56f6fe148a79025c76584832af0">
   <xsd:schema xmlns:xsd="http://www.w3.org/2001/XMLSchema" xmlns:xs="http://www.w3.org/2001/XMLSchema" xmlns:p="http://schemas.microsoft.com/office/2006/metadata/properties" xmlns:ns2="a1a2d923-8fea-42f1-bd41-9cdfff65694e" targetNamespace="http://schemas.microsoft.com/office/2006/metadata/properties" ma:root="true" ma:fieldsID="97c8655d467eaa9470a714421e7268c0" ns2:_="">
     <xsd:import namespace="a1a2d923-8fea-42f1-bd41-9cdfff65694e"/>
@@ -41604,15 +42265,16 @@
 </ct:contentTypeSchema>
 </file>
 
-<file path=customXml/itemProps1.xml><?xml version="1.0" encoding="utf-8"?>
-<ds:datastoreItem xmlns:ds="http://schemas.openxmlformats.org/officeDocument/2006/customXml" ds:itemID="{9DC439CA-6F1C-4005-ACA6-A52E04DEE0A7}">
-  <ds:schemaRefs>
-    <ds:schemaRef ds:uri="http://schemas.microsoft.com/sharepoint/v3/contenttype/forms"/>
-  </ds:schemaRefs>
-</ds:datastoreItem>
+<file path=customXml/item3.xml><?xml version="1.0" encoding="utf-8"?>
+<?mso-contentType ?>
+<FormTemplates xmlns="http://schemas.microsoft.com/sharepoint/v3/contenttype/forms">
+  <Display>DocumentLibraryForm</Display>
+  <Edit>DocumentLibraryForm</Edit>
+  <New>DocumentLibraryForm</New>
+</FormTemplates>
 </file>
 
-<file path=customXml/itemProps2.xml><?xml version="1.0" encoding="utf-8"?>
+<file path=customXml/itemProps1.xml><?xml version="1.0" encoding="utf-8"?>
 <ds:datastoreItem xmlns:ds="http://schemas.openxmlformats.org/officeDocument/2006/customXml" ds:itemID="{5BDF4908-A52A-47DD-A794-6E02D71942FC}">
   <ds:schemaRefs>
     <ds:schemaRef ds:uri="http://schemas.microsoft.com/office/2006/metadata/properties"/>
@@ -41621,7 +42283,7 @@
 </ds:datastoreItem>
 </file>
 
-<file path=customXml/itemProps3.xml><?xml version="1.0" encoding="utf-8"?>
+<file path=customXml/itemProps2.xml><?xml version="1.0" encoding="utf-8"?>
 <ds:datastoreItem xmlns:ds="http://schemas.openxmlformats.org/officeDocument/2006/customXml" ds:itemID="{9CF4F972-2392-44D0-AA45-41AC4FDC4A59}">
   <ds:schemaRefs>
     <ds:schemaRef ds:uri="a1a2d923-8fea-42f1-bd41-9cdfff65694e"/>
@@ -41637,4 +42299,12 @@
     <ds:schemaRef ds:uri="http://www.w3.org/2001/XMLSchema"/>
   </ds:schemaRefs>
 </ds:datastoreItem>
+</file>
+
+<file path=customXml/itemProps3.xml><?xml version="1.0" encoding="utf-8"?>
+<ds:datastoreItem xmlns:ds="http://schemas.openxmlformats.org/officeDocument/2006/customXml" ds:itemID="{9DC439CA-6F1C-4005-ACA6-A52E04DEE0A7}">
+  <ds:schemaRefs>
+    <ds:schemaRef ds:uri="http://schemas.microsoft.com/sharepoint/v3/contenttype/forms"/>
+  </ds:schemaRefs>
+</ds:datastoreItem>
 </file>
</xml_diff>